<commit_message>
Add statistical explanations of binomial GP and RESuM to slides
</commit_message>
<xml_diff>
--- a/presentations/binomial_gp_vs_resum/binomial_gp_vs_resum.pptx
+++ b/presentations/binomial_gp_vs_resum/binomial_gp_vs_resum.pptx
@@ -20,6 +20,8 @@
     <p:sldId id="268" r:id="rId20"/>
     <p:sldId id="269" r:id="rId21"/>
     <p:sldId id="270" r:id="rId22"/>
+    <p:sldId id="271" r:id="rId23"/>
+    <p:sldId id="272" r:id="rId24"/>
   </p:sldIdLst>
   <p:sldSz cx="12191695" cy="6858000" type="screen4x3"/>
   <p:notesSz cx="6858000" cy="9144000"/>
@@ -796,7 +798,7 @@
           <a:lstStyle/>
           <a:p>
             <a:r>
-              <a:t>GPML chapter3 supports logistic Gaussian processes and Laplace approximation. The current grouped binomial model uses event counts directly. GP prior is Matérn5/2+Bias, ARD lengthscales; RBF optional. It assumes independent primary detections within each voxel population. Hyperparameters are optimized rather than marginalized.</a:t>
+              <a:t>Input s_i is a voxel center, m_i is the integer number of hit-producing primaries, and N_i is the known total number of simulated primaries. A GP prior acts on log-odds f. The logistic link bounds p. Conditional independence gives a product of binomial likelihoods over runs. The posterior is not analytically Gaussian; the implemented Laplace approximation is centered at its mode. Kernel parameters are optimized by approximate evidence, and their uncertainty is not integrated. Same physics and primary-generation distribution are required to use one probability field. Source: core/binomial_gp.py; GPML chapter 3.</a:t>
             </a:r>
           </a:p>
         </p:txBody>
@@ -866,7 +868,7 @@
           <a:lstStyle/>
           <a:p>
             <a:r>
-              <a:t>Exact artifact directories: outputs/optical_binomial/20261001T173754_521023Z and outputs/optical_resum/notebook/20260930T195141_282030Z. Counts and split information verified from saved artifacts. Nonzero-only LF selection affects the older workflow. These snapshots should not be interpreted as matched evaluation.</a:t>
+              <a:t>This slide describes the current optical-map configuration, not every possible RESuM model. The two-output CNP predicts a distribution whose approximate mean q_j enters the theory-truth Bernoulli cross-entropy; class-aware mixup can provide soft labels and is not an ordinary natural-frequency sample. Average event probabilities to obtain b_i. The three spatial GP output levels are LF CNP mean, HF CNP mean and HF raw fraction. For the current log-space fit, the HF raw training rate is smoothed as (m+0.5)/(N+1); nonpositive CNP means are floored before taking logs. The linear multifidelity kernel implements g_l(s)=rho_l*g_(l-1)(s)+delta_l(s), with independent GP discrepancies and Gaussian observation noise per level. Gaussian conditioning is analytic conditional on fitted kernel/noise parameters. CNP scale is not used as GP noise and its full uncertainty is not propagated. Sources: core/surrogate_cnp.py, core/surrogates/mfgp_stage.py, core/surrogate_mfgp.py.</a:t>
             </a:r>
           </a:p>
         </p:txBody>
@@ -892,6 +894,146 @@
 </file>
 
 <file path=ppt/notesSlides/notesSlide15.xml><?xml version="1.0" encoding="utf-8"?>
+<p:notes xmlns:a="http://schemas.openxmlformats.org/drawingml/2006/main" xmlns:p="http://schemas.openxmlformats.org/presentationml/2006/main" xmlns:r="http://schemas.openxmlformats.org/officeDocument/2006/relationships">
+  <p:cSld>
+    <p:spTree>
+      <p:nvGrpSpPr>
+        <p:cNvPr id="1" name=""/>
+        <p:cNvGrpSpPr/>
+        <p:nvPr/>
+      </p:nvGrpSpPr>
+      <p:grpSpPr>
+        <a:xfrm>
+          <a:off x="0" y="0"/>
+          <a:ext cx="0" cy="0"/>
+          <a:chOff x="0" y="0"/>
+          <a:chExt cx="0" cy="0"/>
+        </a:xfrm>
+      </p:grpSpPr>
+      <p:sp>
+        <p:nvSpPr>
+          <p:cNvPr id="2" name="Slide Image Placeholder 1"/>
+          <p:cNvSpPr>
+            <a:spLocks noGrp="1"/>
+          </p:cNvSpPr>
+          <p:nvPr>
+            <p:ph type="sldImg" idx="2"/>
+          </p:nvPr>
+        </p:nvSpPr>
+        <p:spPr/>
+      </p:sp>
+      <p:sp>
+        <p:nvSpPr>
+          <p:cNvPr id="3" name="Notes Placeholder 2"/>
+          <p:cNvSpPr>
+            <a:spLocks noGrp="1"/>
+          </p:cNvSpPr>
+          <p:nvPr>
+            <p:ph type="body" idx="3" sz="quarter"/>
+          </p:nvPr>
+        </p:nvSpPr>
+        <p:spPr/>
+        <p:txBody>
+          <a:bodyPr/>
+          <a:lstStyle/>
+          <a:p>
+            <a:r>
+              <a:t>GPML chapter3 supports logistic Gaussian processes and Laplace approximation. The current grouped binomial model uses event counts directly. GP prior is Matérn5/2+Bias, ARD lengthscales; RBF optional. It assumes independent primary detections within each voxel population. Hyperparameters are optimized rather than marginalized.</a:t>
+            </a:r>
+          </a:p>
+        </p:txBody>
+      </p:sp>
+      <p:sp>
+        <p:nvSpPr>
+          <p:cNvPr id="4" name="Slide Number Placeholder 3"/>
+          <p:cNvSpPr>
+            <a:spLocks noGrp="1"/>
+          </p:cNvSpPr>
+          <p:nvPr>
+            <p:ph type="sldNum" idx="5" sz="quarter"/>
+          </p:nvPr>
+        </p:nvSpPr>
+        <p:spPr/>
+      </p:sp>
+    </p:spTree>
+  </p:cSld>
+  <p:clrMapOvr>
+    <a:masterClrMapping/>
+  </p:clrMapOvr>
+</p:notes>
+</file>
+
+<file path=ppt/notesSlides/notesSlide16.xml><?xml version="1.0" encoding="utf-8"?>
+<p:notes xmlns:a="http://schemas.openxmlformats.org/drawingml/2006/main" xmlns:p="http://schemas.openxmlformats.org/presentationml/2006/main" xmlns:r="http://schemas.openxmlformats.org/officeDocument/2006/relationships">
+  <p:cSld>
+    <p:spTree>
+      <p:nvGrpSpPr>
+        <p:cNvPr id="1" name=""/>
+        <p:cNvGrpSpPr/>
+        <p:nvPr/>
+      </p:nvGrpSpPr>
+      <p:grpSpPr>
+        <a:xfrm>
+          <a:off x="0" y="0"/>
+          <a:ext cx="0" cy="0"/>
+          <a:chOff x="0" y="0"/>
+          <a:chExt cx="0" cy="0"/>
+        </a:xfrm>
+      </p:grpSpPr>
+      <p:sp>
+        <p:nvSpPr>
+          <p:cNvPr id="2" name="Slide Image Placeholder 1"/>
+          <p:cNvSpPr>
+            <a:spLocks noGrp="1"/>
+          </p:cNvSpPr>
+          <p:nvPr>
+            <p:ph type="sldImg" idx="2"/>
+          </p:nvPr>
+        </p:nvSpPr>
+        <p:spPr/>
+      </p:sp>
+      <p:sp>
+        <p:nvSpPr>
+          <p:cNvPr id="3" name="Notes Placeholder 2"/>
+          <p:cNvSpPr>
+            <a:spLocks noGrp="1"/>
+          </p:cNvSpPr>
+          <p:nvPr>
+            <p:ph type="body" idx="3" sz="quarter"/>
+          </p:nvPr>
+        </p:nvSpPr>
+        <p:spPr/>
+        <p:txBody>
+          <a:bodyPr/>
+          <a:lstStyle/>
+          <a:p>
+            <a:r>
+              <a:t>Exact artifact directories: outputs/optical_binomial/20261001T173754_521023Z and outputs/optical_resum/notebook/20260930T195141_282030Z. Counts and split information verified from saved artifacts. Nonzero-only LF selection affects the older workflow. These snapshots should not be interpreted as matched evaluation.</a:t>
+            </a:r>
+          </a:p>
+        </p:txBody>
+      </p:sp>
+      <p:sp>
+        <p:nvSpPr>
+          <p:cNvPr id="4" name="Slide Number Placeholder 3"/>
+          <p:cNvSpPr>
+            <a:spLocks noGrp="1"/>
+          </p:cNvSpPr>
+          <p:nvPr>
+            <p:ph type="sldNum" idx="5" sz="quarter"/>
+          </p:nvPr>
+        </p:nvSpPr>
+        <p:spPr/>
+      </p:sp>
+    </p:spTree>
+  </p:cSld>
+  <p:clrMapOvr>
+    <a:masterClrMapping/>
+  </p:clrMapOvr>
+</p:notes>
+</file>
+
+<file path=ppt/notesSlides/notesSlide17.xml><?xml version="1.0" encoding="utf-8"?>
 <p:notes xmlns:a="http://schemas.openxmlformats.org/drawingml/2006/main" xmlns:p="http://schemas.openxmlformats.org/presentationml/2006/main" xmlns:r="http://schemas.openxmlformats.org/officeDocument/2006/relationships">
   <p:cSld>
     <p:spTree>
@@ -11968,7 +12110,7 @@
               </a:defRPr>
             </a:pPr>
             <a:r>
-              <a:t>APPENDIX • EQUATIONS</a:t>
+              <a:t>STATISTICAL EXPLANATION</a:t>
             </a:r>
           </a:p>
         </p:txBody>
@@ -12010,7 +12152,7 @@
               </a:defRPr>
             </a:pPr>
             <a:r>
-              <a:t>Technical appendix: what is the binomial GP?</a:t>
+              <a:t>Binomial GP: the statistical model</a:t>
             </a:r>
           </a:p>
         </p:txBody>
@@ -12150,8 +12292,8 @@
         </p:nvSpPr>
         <p:spPr>
           <a:xfrm>
-            <a:off x="594360" y="1737360"/>
-            <a:ext cx="5486400" cy="1965960"/>
+            <a:off x="594360" y="1691640"/>
+            <a:ext cx="5486400" cy="3246120"/>
           </a:xfrm>
           <a:prstGeom prst="rect">
             <a:avLst/>
@@ -12193,8 +12335,8 @@
         </p:nvSpPr>
         <p:spPr>
           <a:xfrm>
-            <a:off x="594360" y="1737360"/>
-            <a:ext cx="64008" cy="1965960"/>
+            <a:off x="594360" y="1691640"/>
+            <a:ext cx="64008" cy="3246120"/>
           </a:xfrm>
           <a:prstGeom prst="rect">
             <a:avLst/>
@@ -12236,7 +12378,7 @@
         </p:nvSpPr>
         <p:spPr>
           <a:xfrm>
-            <a:off x="822960" y="1938528"/>
+            <a:off x="822960" y="1892808"/>
             <a:ext cx="5029200" cy="457200"/>
           </a:xfrm>
           <a:prstGeom prst="rect">
@@ -12252,12 +12394,12 @@
           <a:p>
             <a:pPr>
               <a:lnSpc>
-                <a:spcPts val="2760"/>
+                <a:spcPts val="2144"/>
               </a:lnSpc>
               <a:spcAft>
                 <a:spcPts val="0"/>
               </a:spcAft>
-              <a:defRPr sz="2300" b="1">
+              <a:defRPr sz="1787" b="1">
                 <a:solidFill>
                   <a:srgbClr val="007F83"/>
                 </a:solidFill>
@@ -12265,7 +12407,7 @@
               </a:defRPr>
             </a:pPr>
             <a:r>
-              <a:t>1 Spatial pattern</a:t>
+              <a:t>Prior: how probabilities vary in space</a:t>
             </a:r>
           </a:p>
         </p:txBody>
@@ -12278,8 +12420,8 @@
         </p:nvSpPr>
         <p:spPr>
           <a:xfrm>
-            <a:off x="822960" y="2578608"/>
-            <a:ext cx="5029200" cy="1097280"/>
+            <a:off x="822960" y="2532888"/>
+            <a:ext cx="5029200" cy="2377439"/>
           </a:xfrm>
           <a:prstGeom prst="rect">
             <a:avLst/>
@@ -12342,9 +12484,63 @@
               </a:defRPr>
             </a:pPr>
             <a:r>
-              <a:t>p(s) = 1 / [1 + exp(−f(s))]</a:t>
+              <a:t>p(s) = sigmoid[f(s)]</a:t>
             </a:r>
           </a:p>
+          <a:p>
+            <a:pPr>
+              <a:lnSpc>
+                <a:spcPts val="2400"/>
+              </a:lnSpc>
+              <a:spcAft>
+                <a:spcPts val="0"/>
+              </a:spcAft>
+              <a:defRPr sz="2000" b="0">
+                <a:solidFill>
+                  <a:srgbClr val="142E43"/>
+                </a:solidFill>
+                <a:latin typeface="DejaVu Sans"/>
+              </a:defRPr>
+            </a:pPr>
+          </a:p>
+          <a:p>
+            <a:pPr>
+              <a:lnSpc>
+                <a:spcPts val="2400"/>
+              </a:lnSpc>
+              <a:spcAft>
+                <a:spcPts val="0"/>
+              </a:spcAft>
+              <a:defRPr sz="2000" b="0">
+                <a:solidFill>
+                  <a:srgbClr val="142E43"/>
+                </a:solidFill>
+                <a:latin typeface="DejaVu Sans"/>
+              </a:defRPr>
+            </a:pPr>
+            <a:r>
+              <a:t>The kernel k links nearby locations.</a:t>
+            </a:r>
+          </a:p>
+          <a:p>
+            <a:pPr>
+              <a:lnSpc>
+                <a:spcPts val="2400"/>
+              </a:lnSpc>
+              <a:spcAft>
+                <a:spcPts val="0"/>
+              </a:spcAft>
+              <a:defRPr sz="2000" b="0">
+                <a:solidFill>
+                  <a:srgbClr val="142E43"/>
+                </a:solidFill>
+                <a:latin typeface="DejaVu Sans"/>
+              </a:defRPr>
+            </a:pPr>
+            <a:r>
+              <a:t>The sigmoid keeps 0 &lt; p &lt; 1.</a:t>
+            </a:r>
+          </a:p>
         </p:txBody>
       </p:sp>
       <p:sp>
@@ -12355,8 +12551,8 @@
         </p:nvSpPr>
         <p:spPr>
           <a:xfrm>
-            <a:off x="6263640" y="1737360"/>
-            <a:ext cx="5303520" cy="1965960"/>
+            <a:off x="6263640" y="1691640"/>
+            <a:ext cx="5303520" cy="3246120"/>
           </a:xfrm>
           <a:prstGeom prst="rect">
             <a:avLst/>
@@ -12398,8 +12594,8 @@
         </p:nvSpPr>
         <p:spPr>
           <a:xfrm>
-            <a:off x="6263640" y="1737360"/>
-            <a:ext cx="64008" cy="1965960"/>
+            <a:off x="6263640" y="1691640"/>
+            <a:ext cx="64008" cy="3246120"/>
           </a:xfrm>
           <a:prstGeom prst="rect">
             <a:avLst/>
@@ -12441,8 +12637,200 @@
         </p:nvSpPr>
         <p:spPr>
           <a:xfrm>
-            <a:off x="6492240" y="1938528"/>
+            <a:off x="6492240" y="1892808"/>
             <a:ext cx="4846320" cy="457200"/>
+          </a:xfrm>
+          <a:prstGeom prst="rect">
+            <a:avLst/>
+          </a:prstGeom>
+          <a:noFill/>
+        </p:spPr>
+        <p:txBody>
+          <a:bodyPr wrap="none" lIns="0" rIns="0" tIns="0" bIns="0">
+            <a:spAutoFit/>
+          </a:bodyPr>
+          <a:lstStyle/>
+          <a:p>
+            <a:pPr>
+              <a:lnSpc>
+                <a:spcPts val="2094"/>
+              </a:lnSpc>
+              <a:spcAft>
+                <a:spcPts val="0"/>
+              </a:spcAft>
+              <a:defRPr sz="1745" b="1">
+                <a:solidFill>
+                  <a:srgbClr val="007F83"/>
+                </a:solidFill>
+                <a:latin typeface="DejaVu Sans"/>
+              </a:defRPr>
+            </a:pPr>
+            <a:r>
+              <a:t>Likelihood: how counts are produced</a:t>
+            </a:r>
+          </a:p>
+        </p:txBody>
+      </p:sp>
+      <p:sp>
+        <p:nvSpPr>
+          <p:cNvPr id="16" name="TextBox 15"/>
+          <p:cNvSpPr txBox="1"/>
+          <p:nvPr/>
+        </p:nvSpPr>
+        <p:spPr>
+          <a:xfrm>
+            <a:off x="6492240" y="2532888"/>
+            <a:ext cx="4846320" cy="2377439"/>
+          </a:xfrm>
+          <a:prstGeom prst="rect">
+            <a:avLst/>
+          </a:prstGeom>
+          <a:noFill/>
+        </p:spPr>
+        <p:txBody>
+          <a:bodyPr wrap="none" lIns="0" rIns="0" tIns="0" bIns="0">
+            <a:spAutoFit/>
+          </a:bodyPr>
+          <a:lstStyle/>
+          <a:p>
+            <a:pPr>
+              <a:lnSpc>
+                <a:spcPts val="2400"/>
+              </a:lnSpc>
+              <a:spcAft>
+                <a:spcPts val="0"/>
+              </a:spcAft>
+              <a:defRPr sz="2000" b="0">
+                <a:solidFill>
+                  <a:srgbClr val="142E43"/>
+                </a:solidFill>
+                <a:latin typeface="DejaVu Sans"/>
+              </a:defRPr>
+            </a:pPr>
+            <a:r>
+              <a:t>mᵢ | p(sᵢ), Nᵢ ~ Binomial(Nᵢ, p(sᵢ))</a:t>
+            </a:r>
+          </a:p>
+          <a:p>
+            <a:pPr>
+              <a:lnSpc>
+                <a:spcPts val="2400"/>
+              </a:lnSpc>
+              <a:spcAft>
+                <a:spcPts val="0"/>
+              </a:spcAft>
+              <a:defRPr sz="2000" b="0">
+                <a:solidFill>
+                  <a:srgbClr val="142E43"/>
+                </a:solidFill>
+                <a:latin typeface="DejaVu Sans"/>
+              </a:defRPr>
+            </a:pPr>
+          </a:p>
+          <a:p>
+            <a:pPr>
+              <a:lnSpc>
+                <a:spcPts val="2400"/>
+              </a:lnSpc>
+              <a:spcAft>
+                <a:spcPts val="0"/>
+              </a:spcAft>
+              <a:defRPr sz="2000" b="0">
+                <a:solidFill>
+                  <a:srgbClr val="142E43"/>
+                </a:solidFill>
+                <a:latin typeface="DejaVu Sans"/>
+              </a:defRPr>
+            </a:pPr>
+            <a:r>
+              <a:t>Each file contributes its count and</a:t>
+            </a:r>
+          </a:p>
+          <a:p>
+            <a:pPr>
+              <a:lnSpc>
+                <a:spcPts val="2400"/>
+              </a:lnSpc>
+              <a:spcAft>
+                <a:spcPts val="0"/>
+              </a:spcAft>
+              <a:defRPr sz="2000" b="0">
+                <a:solidFill>
+                  <a:srgbClr val="142E43"/>
+                </a:solidFill>
+                <a:latin typeface="DejaVu Sans"/>
+              </a:defRPr>
+            </a:pPr>
+            <a:r>
+              <a:t>budget.</a:t>
+            </a:r>
+          </a:p>
+          <a:p>
+            <a:pPr>
+              <a:lnSpc>
+                <a:spcPts val="2400"/>
+              </a:lnSpc>
+              <a:spcAft>
+                <a:spcPts val="0"/>
+              </a:spcAft>
+              <a:defRPr sz="2000" b="0">
+                <a:solidFill>
+                  <a:srgbClr val="142E43"/>
+                </a:solidFill>
+                <a:latin typeface="DejaVu Sans"/>
+              </a:defRPr>
+            </a:pPr>
+          </a:p>
+          <a:p>
+            <a:pPr>
+              <a:lnSpc>
+                <a:spcPts val="2400"/>
+              </a:lnSpc>
+              <a:spcAft>
+                <a:spcPts val="0"/>
+              </a:spcAft>
+              <a:defRPr sz="2000" b="0">
+                <a:solidFill>
+                  <a:srgbClr val="142E43"/>
+                </a:solidFill>
+                <a:latin typeface="DejaVu Sans"/>
+              </a:defRPr>
+            </a:pPr>
+            <a:r>
+              <a:t>Conditional counting variance:</a:t>
+            </a:r>
+          </a:p>
+          <a:p>
+            <a:pPr>
+              <a:lnSpc>
+                <a:spcPts val="2400"/>
+              </a:lnSpc>
+              <a:spcAft>
+                <a:spcPts val="0"/>
+              </a:spcAft>
+              <a:defRPr sz="2000" b="0">
+                <a:solidFill>
+                  <a:srgbClr val="142E43"/>
+                </a:solidFill>
+                <a:latin typeface="DejaVu Sans"/>
+              </a:defRPr>
+            </a:pPr>
+            <a:r>
+              <a:t>Var(mᵢ / Nᵢ | p) = p(1 − p) / Nᵢ</a:t>
+            </a:r>
+          </a:p>
+        </p:txBody>
+      </p:sp>
+      <p:sp>
+        <p:nvSpPr>
+          <p:cNvPr id="17" name="TextBox 16"/>
+          <p:cNvSpPr txBox="1"/>
+          <p:nvPr/>
+        </p:nvSpPr>
+        <p:spPr>
+          <a:xfrm>
+            <a:off x="777240" y="5166360"/>
+            <a:ext cx="10789920" cy="502920"/>
           </a:xfrm>
           <a:prstGeom prst="rect">
             <a:avLst/>
@@ -12470,175 +12858,14 @@
               </a:defRPr>
             </a:pPr>
             <a:r>
-              <a:t>2 Counts at each voxel</a:t>
+              <a:t>Posterior = prior spatial model updated by all observed counts.</a:t>
             </a:r>
           </a:p>
         </p:txBody>
       </p:sp>
       <p:sp>
         <p:nvSpPr>
-          <p:cNvPr id="16" name="TextBox 15"/>
-          <p:cNvSpPr txBox="1"/>
-          <p:nvPr/>
-        </p:nvSpPr>
-        <p:spPr>
-          <a:xfrm>
-            <a:off x="6492240" y="2578608"/>
-            <a:ext cx="4846320" cy="1097280"/>
-          </a:xfrm>
-          <a:prstGeom prst="rect">
-            <a:avLst/>
-          </a:prstGeom>
-          <a:noFill/>
-        </p:spPr>
-        <p:txBody>
-          <a:bodyPr wrap="none" lIns="0" rIns="0" tIns="0" bIns="0">
-            <a:spAutoFit/>
-          </a:bodyPr>
-          <a:lstStyle/>
-          <a:p>
-            <a:pPr>
-              <a:lnSpc>
-                <a:spcPts val="2400"/>
-              </a:lnSpc>
-              <a:spcAft>
-                <a:spcPts val="0"/>
-              </a:spcAft>
-              <a:defRPr sz="2000" b="0">
-                <a:solidFill>
-                  <a:srgbClr val="142E43"/>
-                </a:solidFill>
-                <a:latin typeface="DejaVu Sans"/>
-              </a:defRPr>
-            </a:pPr>
-            <a:r>
-              <a:t>mᵢ ~ Binomial(Nᵢ, p(sᵢ))</a:t>
-            </a:r>
-          </a:p>
-          <a:p>
-            <a:pPr>
-              <a:lnSpc>
-                <a:spcPts val="2400"/>
-              </a:lnSpc>
-              <a:spcAft>
-                <a:spcPts val="0"/>
-              </a:spcAft>
-              <a:defRPr sz="2000" b="0">
-                <a:solidFill>
-                  <a:srgbClr val="142E43"/>
-                </a:solidFill>
-                <a:latin typeface="DejaVu Sans"/>
-              </a:defRPr>
-            </a:pPr>
-          </a:p>
-          <a:p>
-            <a:pPr>
-              <a:lnSpc>
-                <a:spcPts val="2400"/>
-              </a:lnSpc>
-              <a:spcAft>
-                <a:spcPts val="0"/>
-              </a:spcAft>
-              <a:defRPr sz="2000" b="0">
-                <a:solidFill>
-                  <a:srgbClr val="142E43"/>
-                </a:solidFill>
-                <a:latin typeface="DejaVu Sans"/>
-              </a:defRPr>
-            </a:pPr>
-            <a:r>
-              <a:t>Nᵢ is known; p(sᵢ) is inferred.</a:t>
-            </a:r>
-          </a:p>
-        </p:txBody>
-      </p:sp>
-      <p:sp>
-        <p:nvSpPr>
-          <p:cNvPr id="17" name="TextBox 16"/>
-          <p:cNvSpPr txBox="1"/>
-          <p:nvPr/>
-        </p:nvSpPr>
-        <p:spPr>
-          <a:xfrm>
-            <a:off x="777240" y="4206240"/>
-            <a:ext cx="10515600" cy="457200"/>
-          </a:xfrm>
-          <a:prstGeom prst="rect">
-            <a:avLst/>
-          </a:prstGeom>
-          <a:noFill/>
-        </p:spPr>
-        <p:txBody>
-          <a:bodyPr wrap="none" lIns="0" rIns="0" tIns="0" bIns="0">
-            <a:spAutoFit/>
-          </a:bodyPr>
-          <a:lstStyle/>
-          <a:p>
-            <a:pPr>
-              <a:lnSpc>
-                <a:spcPts val="2879"/>
-              </a:lnSpc>
-              <a:spcAft>
-                <a:spcPts val="0"/>
-              </a:spcAft>
-              <a:defRPr sz="2400" b="1">
-                <a:solidFill>
-                  <a:srgbClr val="142E43"/>
-                </a:solidFill>
-                <a:latin typeface="DejaVu Sans"/>
-              </a:defRPr>
-            </a:pPr>
-            <a:r>
-              <a:t>Predicted fraction variance at an exact location:</a:t>
-            </a:r>
-          </a:p>
-        </p:txBody>
-      </p:sp>
-      <p:sp>
-        <p:nvSpPr>
           <p:cNvPr id="18" name="TextBox 17"/>
-          <p:cNvSpPr txBox="1"/>
-          <p:nvPr/>
-        </p:nvSpPr>
-        <p:spPr>
-          <a:xfrm>
-            <a:off x="777240" y="4846320"/>
-            <a:ext cx="10515600" cy="731520"/>
-          </a:xfrm>
-          <a:prstGeom prst="rect">
-            <a:avLst/>
-          </a:prstGeom>
-          <a:noFill/>
-        </p:spPr>
-        <p:txBody>
-          <a:bodyPr wrap="none" lIns="0" rIns="0" tIns="0" bIns="0">
-            <a:spAutoFit/>
-          </a:bodyPr>
-          <a:lstStyle/>
-          <a:p>
-            <a:pPr>
-              <a:lnSpc>
-                <a:spcPts val="2879"/>
-              </a:lnSpc>
-              <a:spcAft>
-                <a:spcPts val="0"/>
-              </a:spcAft>
-              <a:defRPr sz="2400" b="0">
-                <a:solidFill>
-                  <a:srgbClr val="007F83"/>
-                </a:solidFill>
-                <a:latin typeface="DejaVu Sans"/>
-              </a:defRPr>
-            </a:pPr>
-            <a:r>
-              <a:t>Var(R | s, D) = Var(P | s, D) + E[P(1 − P) | s, D] / N</a:t>
-            </a:r>
-          </a:p>
-        </p:txBody>
-      </p:sp>
-      <p:sp>
-        <p:nvSpPr>
-          <p:cNvPr id="19" name="TextBox 18"/>
           <p:cNvSpPr txBox="1"/>
           <p:nvPr/>
         </p:nvSpPr>
@@ -12673,7 +12900,7 @@
               </a:defRPr>
             </a:pPr>
             <a:r>
-              <a:t>First term: uncertainty in the map. Second term: counting noise. Inference uses a Laplace approximation.</a:t>
+              <a:t>Implemented inference: Laplace approximation; kernel parameters fitted on training data only.</a:t>
             </a:r>
           </a:p>
         </p:txBody>
@@ -12819,7 +13046,7 @@
               </a:defRPr>
             </a:pPr>
             <a:r>
-              <a:t>APPENDIX • EVIDENCE</a:t>
+              <a:t>STATISTICAL EXPLANATION</a:t>
             </a:r>
           </a:p>
         </p:txBody>
@@ -12861,7 +13088,7 @@
               </a:defRPr>
             </a:pPr>
             <a:r>
-              <a:t>Technical appendix: the saved runs differ</a:t>
+              <a:t>RESuM: the statistical model</a:t>
             </a:r>
           </a:p>
         </p:txBody>
@@ -13001,13 +13228,56 @@
         </p:nvSpPr>
         <p:spPr>
           <a:xfrm>
-            <a:off x="502920" y="1691640"/>
-            <a:ext cx="2253996" cy="530352"/>
+            <a:off x="594360" y="1691640"/>
+            <a:ext cx="5486400" cy="3246120"/>
           </a:xfrm>
           <a:prstGeom prst="rect">
             <a:avLst/>
           </a:prstGeom>
           <a:solidFill>
+            <a:srgbClr val="FFFFFF"/>
+          </a:solidFill>
+          <a:ln>
+            <a:noFill/>
+          </a:ln>
+        </p:spPr>
+        <p:style>
+          <a:lnRef idx="1">
+            <a:schemeClr val="accent1"/>
+          </a:lnRef>
+          <a:fillRef idx="3">
+            <a:schemeClr val="accent1"/>
+          </a:fillRef>
+          <a:effectRef idx="2">
+            <a:schemeClr val="accent1"/>
+          </a:effectRef>
+          <a:fontRef idx="minor">
+            <a:schemeClr val="lt1"/>
+          </a:fontRef>
+        </p:style>
+        <p:txBody>
+          <a:bodyPr rtlCol="0" anchor="ctr"/>
+          <a:lstStyle/>
+          <a:p>
+            <a:pPr algn="ctr"/>
+          </a:p>
+        </p:txBody>
+      </p:sp>
+      <p:sp>
+        <p:nvSpPr>
+          <p:cNvPr id="10" name="Rectangle 9"/>
+          <p:cNvSpPr/>
+          <p:nvPr/>
+        </p:nvSpPr>
+        <p:spPr>
+          <a:xfrm>
+            <a:off x="594360" y="1691640"/>
+            <a:ext cx="64008" cy="3246120"/>
+          </a:xfrm>
+          <a:prstGeom prst="rect">
+            <a:avLst/>
+          </a:prstGeom>
+          <a:solidFill>
             <a:srgbClr val="007F83"/>
           </a:solidFill>
           <a:ln>
@@ -13038,14 +13308,14 @@
       </p:sp>
       <p:sp>
         <p:nvSpPr>
-          <p:cNvPr id="10" name="TextBox 9"/>
+          <p:cNvPr id="11" name="TextBox 10"/>
           <p:cNvSpPr txBox="1"/>
           <p:nvPr/>
         </p:nvSpPr>
         <p:spPr>
           <a:xfrm>
-            <a:off x="621792" y="1810512"/>
-            <a:ext cx="2057400" cy="365760"/>
+            <a:off x="822960" y="1892808"/>
+            <a:ext cx="5029200" cy="457200"/>
           </a:xfrm>
           <a:prstGeom prst="rect">
             <a:avLst/>
@@ -13060,159 +13330,34 @@
           <a:p>
             <a:pPr>
               <a:lnSpc>
-                <a:spcPts val="2039"/>
+                <a:spcPts val="2535"/>
               </a:lnSpc>
               <a:spcAft>
                 <a:spcPts val="0"/>
               </a:spcAft>
-              <a:defRPr sz="1700" b="1">
+              <a:defRPr sz="2113" b="1">
                 <a:solidFill>
-                  <a:srgbClr val="FFFFFF"/>
-                </a:solidFill>
-                <a:latin typeface="DejaVu Sans"/>
-              </a:defRPr>
-            </a:pPr>
-          </a:p>
-        </p:txBody>
-      </p:sp>
-      <p:sp>
-        <p:nvSpPr>
-          <p:cNvPr id="11" name="Rectangle 10"/>
-          <p:cNvSpPr/>
-          <p:nvPr/>
-        </p:nvSpPr>
-        <p:spPr>
-          <a:xfrm>
-            <a:off x="2788920" y="1691640"/>
-            <a:ext cx="4174235" cy="530352"/>
-          </a:xfrm>
-          <a:prstGeom prst="rect">
-            <a:avLst/>
-          </a:prstGeom>
-          <a:solidFill>
-            <a:srgbClr val="007F83"/>
-          </a:solidFill>
-          <a:ln>
-            <a:noFill/>
-          </a:ln>
-        </p:spPr>
-        <p:style>
-          <a:lnRef idx="1">
-            <a:schemeClr val="accent1"/>
-          </a:lnRef>
-          <a:fillRef idx="3">
-            <a:schemeClr val="accent1"/>
-          </a:fillRef>
-          <a:effectRef idx="2">
-            <a:schemeClr val="accent1"/>
-          </a:effectRef>
-          <a:fontRef idx="minor">
-            <a:schemeClr val="lt1"/>
-          </a:fontRef>
-        </p:style>
-        <p:txBody>
-          <a:bodyPr rtlCol="0" anchor="ctr"/>
-          <a:lstStyle/>
-          <a:p>
-            <a:pPr algn="ctr"/>
-          </a:p>
-        </p:txBody>
-      </p:sp>
-      <p:sp>
-        <p:nvSpPr>
-          <p:cNvPr id="12" name="TextBox 11"/>
-          <p:cNvSpPr txBox="1"/>
-          <p:nvPr/>
-        </p:nvSpPr>
-        <p:spPr>
-          <a:xfrm>
-            <a:off x="2907791" y="1810512"/>
-            <a:ext cx="3977639" cy="365760"/>
-          </a:xfrm>
-          <a:prstGeom prst="rect">
-            <a:avLst/>
-          </a:prstGeom>
-          <a:noFill/>
-        </p:spPr>
-        <p:txBody>
-          <a:bodyPr wrap="none" lIns="0" rIns="0" tIns="0" bIns="0">
-            <a:spAutoFit/>
-          </a:bodyPr>
-          <a:lstStyle/>
-          <a:p>
-            <a:pPr>
-              <a:lnSpc>
-                <a:spcPts val="2039"/>
-              </a:lnSpc>
-              <a:spcAft>
-                <a:spcPts val="0"/>
-              </a:spcAft>
-              <a:defRPr sz="1700" b="1">
-                <a:solidFill>
-                  <a:srgbClr val="FFFFFF"/>
+                  <a:srgbClr val="007F83"/>
                 </a:solidFill>
                 <a:latin typeface="DejaVu Sans"/>
               </a:defRPr>
             </a:pPr>
             <a:r>
-              <a:t>Saved RESuM</a:t>
+              <a:t>1 CNP: learn event probabilities</a:t>
             </a:r>
           </a:p>
         </p:txBody>
       </p:sp>
       <p:sp>
         <p:nvSpPr>
-          <p:cNvPr id="13" name="Rectangle 12"/>
-          <p:cNvSpPr/>
-          <p:nvPr/>
-        </p:nvSpPr>
-        <p:spPr>
-          <a:xfrm>
-            <a:off x="6995159" y="1691640"/>
-            <a:ext cx="4631436" cy="530352"/>
-          </a:xfrm>
-          <a:prstGeom prst="rect">
-            <a:avLst/>
-          </a:prstGeom>
-          <a:solidFill>
-            <a:srgbClr val="007F83"/>
-          </a:solidFill>
-          <a:ln>
-            <a:noFill/>
-          </a:ln>
-        </p:spPr>
-        <p:style>
-          <a:lnRef idx="1">
-            <a:schemeClr val="accent1"/>
-          </a:lnRef>
-          <a:fillRef idx="3">
-            <a:schemeClr val="accent1"/>
-          </a:fillRef>
-          <a:effectRef idx="2">
-            <a:schemeClr val="accent1"/>
-          </a:effectRef>
-          <a:fontRef idx="minor">
-            <a:schemeClr val="lt1"/>
-          </a:fontRef>
-        </p:style>
-        <p:txBody>
-          <a:bodyPr rtlCol="0" anchor="ctr"/>
-          <a:lstStyle/>
-          <a:p>
-            <a:pPr algn="ctr"/>
-          </a:p>
-        </p:txBody>
-      </p:sp>
-      <p:sp>
-        <p:nvSpPr>
-          <p:cNvPr id="14" name="TextBox 13"/>
+          <p:cNvPr id="12" name="TextBox 11"/>
           <p:cNvSpPr txBox="1"/>
           <p:nvPr/>
         </p:nvSpPr>
         <p:spPr>
           <a:xfrm>
-            <a:off x="7114031" y="1810512"/>
-            <a:ext cx="4434840" cy="365760"/>
+            <a:off x="822960" y="2532888"/>
+            <a:ext cx="5029200" cy="2377439"/>
           </a:xfrm>
           <a:prstGeom prst="rect">
             <a:avLst/>
@@ -13227,97 +13372,12 @@
           <a:p>
             <a:pPr>
               <a:lnSpc>
-                <a:spcPts val="2039"/>
+                <a:spcPts val="2400"/>
               </a:lnSpc>
               <a:spcAft>
                 <a:spcPts val="0"/>
               </a:spcAft>
-              <a:defRPr sz="1700" b="1">
-                <a:solidFill>
-                  <a:srgbClr val="FFFFFF"/>
-                </a:solidFill>
-                <a:latin typeface="DejaVu Sans"/>
-              </a:defRPr>
-            </a:pPr>
-            <a:r>
-              <a:t>Saved binomial GP</a:t>
-            </a:r>
-          </a:p>
-        </p:txBody>
-      </p:sp>
-      <p:sp>
-        <p:nvSpPr>
-          <p:cNvPr id="15" name="Rectangle 14"/>
-          <p:cNvSpPr/>
-          <p:nvPr/>
-        </p:nvSpPr>
-        <p:spPr>
-          <a:xfrm>
-            <a:off x="502920" y="2258568"/>
-            <a:ext cx="2253996" cy="690372"/>
-          </a:xfrm>
-          <a:prstGeom prst="rect">
-            <a:avLst/>
-          </a:prstGeom>
-          <a:solidFill>
-            <a:srgbClr val="FFFFFF"/>
-          </a:solidFill>
-          <a:ln>
-            <a:noFill/>
-          </a:ln>
-        </p:spPr>
-        <p:style>
-          <a:lnRef idx="1">
-            <a:schemeClr val="accent1"/>
-          </a:lnRef>
-          <a:fillRef idx="3">
-            <a:schemeClr val="accent1"/>
-          </a:fillRef>
-          <a:effectRef idx="2">
-            <a:schemeClr val="accent1"/>
-          </a:effectRef>
-          <a:fontRef idx="minor">
-            <a:schemeClr val="lt1"/>
-          </a:fontRef>
-        </p:style>
-        <p:txBody>
-          <a:bodyPr rtlCol="0" anchor="ctr"/>
-          <a:lstStyle/>
-          <a:p>
-            <a:pPr algn="ctr"/>
-          </a:p>
-        </p:txBody>
-      </p:sp>
-      <p:sp>
-        <p:nvSpPr>
-          <p:cNvPr id="16" name="TextBox 15"/>
-          <p:cNvSpPr txBox="1"/>
-          <p:nvPr/>
-        </p:nvSpPr>
-        <p:spPr>
-          <a:xfrm>
-            <a:off x="621792" y="2368296"/>
-            <a:ext cx="2057400" cy="603504"/>
-          </a:xfrm>
-          <a:prstGeom prst="rect">
-            <a:avLst/>
-          </a:prstGeom>
-          <a:noFill/>
-        </p:spPr>
-        <p:txBody>
-          <a:bodyPr wrap="none" lIns="0" rIns="0" tIns="0" bIns="0">
-            <a:spAutoFit/>
-          </a:bodyPr>
-          <a:lstStyle/>
-          <a:p>
-            <a:pPr>
-              <a:lnSpc>
-                <a:spcPts val="1920"/>
-              </a:lnSpc>
-              <a:spcAft>
-                <a:spcPts val="0"/>
-              </a:spcAft>
-              <a:defRPr sz="1600" b="0">
+              <a:defRPr sz="2000" b="0">
                 <a:solidFill>
                   <a:srgbClr val="142E43"/>
                 </a:solidFill>
@@ -13325,84 +13385,34 @@
               </a:defRPr>
             </a:pPr>
             <a:r>
-              <a:t>LF training</a:t>
+              <a:t>qⱼ = CNP-predicted hit probability</a:t>
             </a:r>
           </a:p>
-        </p:txBody>
-      </p:sp>
-      <p:sp>
-        <p:nvSpPr>
-          <p:cNvPr id="17" name="Rectangle 16"/>
-          <p:cNvSpPr/>
-          <p:nvPr/>
-        </p:nvSpPr>
-        <p:spPr>
-          <a:xfrm>
-            <a:off x="2788920" y="2258568"/>
-            <a:ext cx="4174235" cy="690372"/>
-          </a:xfrm>
-          <a:prstGeom prst="rect">
-            <a:avLst/>
-          </a:prstGeom>
-          <a:solidFill>
-            <a:srgbClr val="FFFFFF"/>
-          </a:solidFill>
-          <a:ln>
-            <a:noFill/>
-          </a:ln>
-        </p:spPr>
-        <p:style>
-          <a:lnRef idx="1">
-            <a:schemeClr val="accent1"/>
-          </a:lnRef>
-          <a:fillRef idx="3">
-            <a:schemeClr val="accent1"/>
-          </a:fillRef>
-          <a:effectRef idx="2">
-            <a:schemeClr val="accent1"/>
-          </a:effectRef>
-          <a:fontRef idx="minor">
-            <a:schemeClr val="lt1"/>
-          </a:fontRef>
-        </p:style>
-        <p:txBody>
-          <a:bodyPr rtlCol="0" anchor="ctr"/>
-          <a:lstStyle/>
-          <a:p>
-            <a:pPr algn="ctr"/>
-          </a:p>
-        </p:txBody>
-      </p:sp>
-      <p:sp>
-        <p:nvSpPr>
-          <p:cNvPr id="18" name="TextBox 17"/>
-          <p:cNvSpPr txBox="1"/>
-          <p:nvPr/>
-        </p:nvSpPr>
-        <p:spPr>
-          <a:xfrm>
-            <a:off x="2907791" y="2368296"/>
-            <a:ext cx="3977639" cy="603504"/>
-          </a:xfrm>
-          <a:prstGeom prst="rect">
-            <a:avLst/>
-          </a:prstGeom>
-          <a:noFill/>
-        </p:spPr>
-        <p:txBody>
-          <a:bodyPr wrap="none" lIns="0" rIns="0" tIns="0" bIns="0">
-            <a:spAutoFit/>
-          </a:bodyPr>
-          <a:lstStyle/>
           <a:p>
             <a:pPr>
               <a:lnSpc>
-                <a:spcPts val="1920"/>
+                <a:spcPts val="2400"/>
               </a:lnSpc>
               <a:spcAft>
                 <a:spcPts val="0"/>
               </a:spcAft>
-              <a:defRPr sz="1600" b="0">
+              <a:defRPr sz="2000" b="0">
+                <a:solidFill>
+                  <a:srgbClr val="142E43"/>
+                </a:solidFill>
+                <a:latin typeface="DejaVu Sans"/>
+              </a:defRPr>
+            </a:pPr>
+          </a:p>
+          <a:p>
+            <a:pPr>
+              <a:lnSpc>
+                <a:spcPts val="2400"/>
+              </a:lnSpc>
+              <a:spcAft>
+                <a:spcPts val="0"/>
+              </a:spcAft>
+              <a:defRPr sz="2000" b="0">
                 <a:solidFill>
                   <a:srgbClr val="142E43"/>
                 </a:solidFill>
@@ -13410,84 +13420,34 @@
               </a:defRPr>
             </a:pPr>
             <a:r>
-              <a:t>159 nonzero N1500 voxels</a:t>
+              <a:t>bᵢ = average of qⱼ within voxel i</a:t>
             </a:r>
           </a:p>
-        </p:txBody>
-      </p:sp>
-      <p:sp>
-        <p:nvSpPr>
-          <p:cNvPr id="19" name="Rectangle 18"/>
-          <p:cNvSpPr/>
-          <p:nvPr/>
-        </p:nvSpPr>
-        <p:spPr>
-          <a:xfrm>
-            <a:off x="6995159" y="2258568"/>
-            <a:ext cx="4631436" cy="690372"/>
-          </a:xfrm>
-          <a:prstGeom prst="rect">
-            <a:avLst/>
-          </a:prstGeom>
-          <a:solidFill>
-            <a:srgbClr val="FFFFFF"/>
-          </a:solidFill>
-          <a:ln>
-            <a:noFill/>
-          </a:ln>
-        </p:spPr>
-        <p:style>
-          <a:lnRef idx="1">
-            <a:schemeClr val="accent1"/>
-          </a:lnRef>
-          <a:fillRef idx="3">
-            <a:schemeClr val="accent1"/>
-          </a:fillRef>
-          <a:effectRef idx="2">
-            <a:schemeClr val="accent1"/>
-          </a:effectRef>
-          <a:fontRef idx="minor">
-            <a:schemeClr val="lt1"/>
-          </a:fontRef>
-        </p:style>
-        <p:txBody>
-          <a:bodyPr rtlCol="0" anchor="ctr"/>
-          <a:lstStyle/>
-          <a:p>
-            <a:pPr algn="ctr"/>
-          </a:p>
-        </p:txBody>
-      </p:sp>
-      <p:sp>
-        <p:nvSpPr>
-          <p:cNvPr id="20" name="TextBox 19"/>
-          <p:cNvSpPr txBox="1"/>
-          <p:nvPr/>
-        </p:nvSpPr>
-        <p:spPr>
-          <a:xfrm>
-            <a:off x="7114031" y="2368296"/>
-            <a:ext cx="4434840" cy="603504"/>
-          </a:xfrm>
-          <a:prstGeom prst="rect">
-            <a:avLst/>
-          </a:prstGeom>
-          <a:noFill/>
-        </p:spPr>
-        <p:txBody>
-          <a:bodyPr wrap="none" lIns="0" rIns="0" tIns="0" bIns="0">
-            <a:spAutoFit/>
-          </a:bodyPr>
-          <a:lstStyle/>
           <a:p>
             <a:pPr>
               <a:lnSpc>
-                <a:spcPts val="1920"/>
+                <a:spcPts val="2400"/>
               </a:lnSpc>
               <a:spcAft>
                 <a:spcPts val="0"/>
               </a:spcAft>
-              <a:defRPr sz="1600" b="0">
+              <a:defRPr sz="2000" b="0">
+                <a:solidFill>
+                  <a:srgbClr val="142E43"/>
+                </a:solidFill>
+                <a:latin typeface="DejaVu Sans"/>
+              </a:defRPr>
+            </a:pPr>
+          </a:p>
+          <a:p>
+            <a:pPr>
+              <a:lnSpc>
+                <a:spcPts val="2400"/>
+              </a:lnSpc>
+              <a:spcAft>
+                <a:spcPts val="0"/>
+              </a:spcAft>
+              <a:defRPr sz="2000" b="0">
                 <a:solidFill>
                   <a:srgbClr val="142E43"/>
                 </a:solidFill>
@@ -13495,84 +13455,18 @@
               </a:defRPr>
             </a:pPr>
             <a:r>
-              <a:t>760 across N500–N1500; includes zeros</a:t>
+              <a:t>Current training uses Bernoulli</a:t>
             </a:r>
           </a:p>
-        </p:txBody>
-      </p:sp>
-      <p:sp>
-        <p:nvSpPr>
-          <p:cNvPr id="21" name="Rectangle 20"/>
-          <p:cNvSpPr/>
-          <p:nvPr/>
-        </p:nvSpPr>
-        <p:spPr>
-          <a:xfrm>
-            <a:off x="502920" y="2971800"/>
-            <a:ext cx="2253996" cy="690372"/>
-          </a:xfrm>
-          <a:prstGeom prst="rect">
-            <a:avLst/>
-          </a:prstGeom>
-          <a:solidFill>
-            <a:srgbClr val="E8EFF3"/>
-          </a:solidFill>
-          <a:ln>
-            <a:noFill/>
-          </a:ln>
-        </p:spPr>
-        <p:style>
-          <a:lnRef idx="1">
-            <a:schemeClr val="accent1"/>
-          </a:lnRef>
-          <a:fillRef idx="3">
-            <a:schemeClr val="accent1"/>
-          </a:fillRef>
-          <a:effectRef idx="2">
-            <a:schemeClr val="accent1"/>
-          </a:effectRef>
-          <a:fontRef idx="minor">
-            <a:schemeClr val="lt1"/>
-          </a:fontRef>
-        </p:style>
-        <p:txBody>
-          <a:bodyPr rtlCol="0" anchor="ctr"/>
-          <a:lstStyle/>
-          <a:p>
-            <a:pPr algn="ctr"/>
-          </a:p>
-        </p:txBody>
-      </p:sp>
-      <p:sp>
-        <p:nvSpPr>
-          <p:cNvPr id="22" name="TextBox 21"/>
-          <p:cNvSpPr txBox="1"/>
-          <p:nvPr/>
-        </p:nvSpPr>
-        <p:spPr>
-          <a:xfrm>
-            <a:off x="621792" y="3081528"/>
-            <a:ext cx="2057400" cy="603504"/>
-          </a:xfrm>
-          <a:prstGeom prst="rect">
-            <a:avLst/>
-          </a:prstGeom>
-          <a:noFill/>
-        </p:spPr>
-        <p:txBody>
-          <a:bodyPr wrap="none" lIns="0" rIns="0" tIns="0" bIns="0">
-            <a:spAutoFit/>
-          </a:bodyPr>
-          <a:lstStyle/>
           <a:p>
             <a:pPr>
               <a:lnSpc>
-                <a:spcPts val="1920"/>
+                <a:spcPts val="2400"/>
               </a:lnSpc>
               <a:spcAft>
                 <a:spcPts val="0"/>
               </a:spcAft>
-              <a:defRPr sz="1600" b="0">
+              <a:defRPr sz="2000" b="0">
                 <a:solidFill>
                   <a:srgbClr val="142E43"/>
                 </a:solidFill>
@@ -13580,64 +13474,107 @@
               </a:defRPr>
             </a:pPr>
             <a:r>
-              <a:t>HF training</a:t>
+              <a:t>cross-entropy, with mixup.</a:t>
             </a:r>
           </a:p>
         </p:txBody>
       </p:sp>
       <p:sp>
         <p:nvSpPr>
-          <p:cNvPr id="23" name="Rectangle 22"/>
-          <p:cNvSpPr/>
-          <p:nvPr/>
-        </p:nvSpPr>
-        <p:spPr>
-          <a:xfrm>
-            <a:off x="2788920" y="2971800"/>
-            <a:ext cx="4174235" cy="690372"/>
+          <p:cNvPr id="13" name="Rectangle 12"/>
+          <p:cNvSpPr/>
+          <p:nvPr/>
+        </p:nvSpPr>
+        <p:spPr>
+          <a:xfrm>
+            <a:off x="6263640" y="1691640"/>
+            <a:ext cx="5303520" cy="3246120"/>
           </a:xfrm>
           <a:prstGeom prst="rect">
             <a:avLst/>
           </a:prstGeom>
           <a:solidFill>
-            <a:srgbClr val="E8EFF3"/>
-          </a:solidFill>
-          <a:ln>
-            <a:noFill/>
-          </a:ln>
-        </p:spPr>
-        <p:style>
-          <a:lnRef idx="1">
-            <a:schemeClr val="accent1"/>
-          </a:lnRef>
-          <a:fillRef idx="3">
-            <a:schemeClr val="accent1"/>
-          </a:fillRef>
-          <a:effectRef idx="2">
-            <a:schemeClr val="accent1"/>
-          </a:effectRef>
-          <a:fontRef idx="minor">
-            <a:schemeClr val="lt1"/>
-          </a:fontRef>
-        </p:style>
-        <p:txBody>
-          <a:bodyPr rtlCol="0" anchor="ctr"/>
-          <a:lstStyle/>
-          <a:p>
-            <a:pPr algn="ctr"/>
-          </a:p>
-        </p:txBody>
-      </p:sp>
-      <p:sp>
-        <p:nvSpPr>
-          <p:cNvPr id="24" name="TextBox 23"/>
+            <a:srgbClr val="FFFFFF"/>
+          </a:solidFill>
+          <a:ln>
+            <a:noFill/>
+          </a:ln>
+        </p:spPr>
+        <p:style>
+          <a:lnRef idx="1">
+            <a:schemeClr val="accent1"/>
+          </a:lnRef>
+          <a:fillRef idx="3">
+            <a:schemeClr val="accent1"/>
+          </a:fillRef>
+          <a:effectRef idx="2">
+            <a:schemeClr val="accent1"/>
+          </a:effectRef>
+          <a:fontRef idx="minor">
+            <a:schemeClr val="lt1"/>
+          </a:fontRef>
+        </p:style>
+        <p:txBody>
+          <a:bodyPr rtlCol="0" anchor="ctr"/>
+          <a:lstStyle/>
+          <a:p>
+            <a:pPr algn="ctr"/>
+          </a:p>
+        </p:txBody>
+      </p:sp>
+      <p:sp>
+        <p:nvSpPr>
+          <p:cNvPr id="14" name="Rectangle 13"/>
+          <p:cNvSpPr/>
+          <p:nvPr/>
+        </p:nvSpPr>
+        <p:spPr>
+          <a:xfrm>
+            <a:off x="6263640" y="1691640"/>
+            <a:ext cx="64008" cy="3246120"/>
+          </a:xfrm>
+          <a:prstGeom prst="rect">
+            <a:avLst/>
+          </a:prstGeom>
+          <a:solidFill>
+            <a:srgbClr val="007F83"/>
+          </a:solidFill>
+          <a:ln>
+            <a:noFill/>
+          </a:ln>
+        </p:spPr>
+        <p:style>
+          <a:lnRef idx="1">
+            <a:schemeClr val="accent1"/>
+          </a:lnRef>
+          <a:fillRef idx="3">
+            <a:schemeClr val="accent1"/>
+          </a:fillRef>
+          <a:effectRef idx="2">
+            <a:schemeClr val="accent1"/>
+          </a:effectRef>
+          <a:fontRef idx="minor">
+            <a:schemeClr val="lt1"/>
+          </a:fontRef>
+        </p:style>
+        <p:txBody>
+          <a:bodyPr rtlCol="0" anchor="ctr"/>
+          <a:lstStyle/>
+          <a:p>
+            <a:pPr algn="ctr"/>
+          </a:p>
+        </p:txBody>
+      </p:sp>
+      <p:sp>
+        <p:nvSpPr>
+          <p:cNvPr id="15" name="TextBox 14"/>
           <p:cNvSpPr txBox="1"/>
           <p:nvPr/>
         </p:nvSpPr>
         <p:spPr>
           <a:xfrm>
-            <a:off x="2907791" y="3081528"/>
-            <a:ext cx="3977639" cy="603504"/>
+            <a:off x="6492240" y="1892808"/>
+            <a:ext cx="4846320" cy="457200"/>
           </a:xfrm>
           <a:prstGeom prst="rect">
             <a:avLst/>
@@ -13652,12 +13589,54 @@
           <a:p>
             <a:pPr>
               <a:lnSpc>
-                <a:spcPts val="1920"/>
+                <a:spcPts val="2205"/>
               </a:lnSpc>
               <a:spcAft>
                 <a:spcPts val="0"/>
               </a:spcAft>
-              <a:defRPr sz="1600" b="0">
+              <a:defRPr sz="1837" b="1">
+                <a:solidFill>
+                  <a:srgbClr val="007F83"/>
+                </a:solidFill>
+                <a:latin typeface="DejaVu Sans"/>
+              </a:defRPr>
+            </a:pPr>
+            <a:r>
+              <a:t>2 MFGP: link the spatial summaries</a:t>
+            </a:r>
+          </a:p>
+        </p:txBody>
+      </p:sp>
+      <p:sp>
+        <p:nvSpPr>
+          <p:cNvPr id="16" name="TextBox 15"/>
+          <p:cNvSpPr txBox="1"/>
+          <p:nvPr/>
+        </p:nvSpPr>
+        <p:spPr>
+          <a:xfrm>
+            <a:off x="6492240" y="2532888"/>
+            <a:ext cx="4846320" cy="2377439"/>
+          </a:xfrm>
+          <a:prstGeom prst="rect">
+            <a:avLst/>
+          </a:prstGeom>
+          <a:noFill/>
+        </p:spPr>
+        <p:txBody>
+          <a:bodyPr wrap="none" lIns="0" rIns="0" tIns="0" bIns="0">
+            <a:spAutoFit/>
+          </a:bodyPr>
+          <a:lstStyle/>
+          <a:p>
+            <a:pPr>
+              <a:lnSpc>
+                <a:spcPts val="2400"/>
+              </a:lnSpc>
+              <a:spcAft>
+                <a:spcPts val="0"/>
+              </a:spcAft>
+              <a:defRPr sz="2000" b="0">
                 <a:solidFill>
                   <a:srgbClr val="142E43"/>
                 </a:solidFill>
@@ -13665,84 +13644,34 @@
               </a:defRPr>
             </a:pPr>
             <a:r>
-              <a:t>10 nonzero voxels</a:t>
+              <a:t>gₗ(s) = ρₗ gₗ₋₁(s) + δₗ(s)</a:t>
             </a:r>
           </a:p>
-        </p:txBody>
-      </p:sp>
-      <p:sp>
-        <p:nvSpPr>
-          <p:cNvPr id="25" name="Rectangle 24"/>
-          <p:cNvSpPr/>
-          <p:nvPr/>
-        </p:nvSpPr>
-        <p:spPr>
-          <a:xfrm>
-            <a:off x="6995159" y="2971800"/>
-            <a:ext cx="4631436" cy="690372"/>
-          </a:xfrm>
-          <a:prstGeom prst="rect">
-            <a:avLst/>
-          </a:prstGeom>
-          <a:solidFill>
-            <a:srgbClr val="E8EFF3"/>
-          </a:solidFill>
-          <a:ln>
-            <a:noFill/>
-          </a:ln>
-        </p:spPr>
-        <p:style>
-          <a:lnRef idx="1">
-            <a:schemeClr val="accent1"/>
-          </a:lnRef>
-          <a:fillRef idx="3">
-            <a:schemeClr val="accent1"/>
-          </a:fillRef>
-          <a:effectRef idx="2">
-            <a:schemeClr val="accent1"/>
-          </a:effectRef>
-          <a:fontRef idx="minor">
-            <a:schemeClr val="lt1"/>
-          </a:fontRef>
-        </p:style>
-        <p:txBody>
-          <a:bodyPr rtlCol="0" anchor="ctr"/>
-          <a:lstStyle/>
-          <a:p>
-            <a:pPr algn="ctr"/>
-          </a:p>
-        </p:txBody>
-      </p:sp>
-      <p:sp>
-        <p:nvSpPr>
-          <p:cNvPr id="26" name="TextBox 25"/>
-          <p:cNvSpPr txBox="1"/>
-          <p:nvPr/>
-        </p:nvSpPr>
-        <p:spPr>
-          <a:xfrm>
-            <a:off x="7114031" y="3081528"/>
-            <a:ext cx="4434840" cy="603504"/>
-          </a:xfrm>
-          <a:prstGeom prst="rect">
-            <a:avLst/>
-          </a:prstGeom>
-          <a:noFill/>
-        </p:spPr>
-        <p:txBody>
-          <a:bodyPr wrap="none" lIns="0" rIns="0" tIns="0" bIns="0">
-            <a:spAutoFit/>
-          </a:bodyPr>
-          <a:lstStyle/>
           <a:p>
             <a:pPr>
               <a:lnSpc>
-                <a:spcPts val="1920"/>
+                <a:spcPts val="2400"/>
               </a:lnSpc>
               <a:spcAft>
                 <a:spcPts val="0"/>
               </a:spcAft>
-              <a:defRPr sz="1600" b="0">
+              <a:defRPr sz="2000" b="0">
+                <a:solidFill>
+                  <a:srgbClr val="142E43"/>
+                </a:solidFill>
+                <a:latin typeface="DejaVu Sans"/>
+              </a:defRPr>
+            </a:pPr>
+          </a:p>
+          <a:p>
+            <a:pPr>
+              <a:lnSpc>
+                <a:spcPts val="2400"/>
+              </a:lnSpc>
+              <a:spcAft>
+                <a:spcPts val="0"/>
+              </a:spcAft>
+              <a:defRPr sz="2000" b="0">
                 <a:solidFill>
                   <a:srgbClr val="142E43"/>
                 </a:solidFill>
@@ -13750,84 +13679,34 @@
               </a:defRPr>
             </a:pPr>
             <a:r>
-              <a:t>10 voxels, including 1 zero-hit</a:t>
+              <a:t>zₗ(s) = gₗ(s) + εₗ, εₗ ~ Normal(0, σₗ²)</a:t>
             </a:r>
           </a:p>
-        </p:txBody>
-      </p:sp>
-      <p:sp>
-        <p:nvSpPr>
-          <p:cNvPr id="27" name="Rectangle 26"/>
-          <p:cNvSpPr/>
-          <p:nvPr/>
-        </p:nvSpPr>
-        <p:spPr>
-          <a:xfrm>
-            <a:off x="502920" y="3685032"/>
-            <a:ext cx="2253996" cy="690372"/>
-          </a:xfrm>
-          <a:prstGeom prst="rect">
-            <a:avLst/>
-          </a:prstGeom>
-          <a:solidFill>
-            <a:srgbClr val="FFFFFF"/>
-          </a:solidFill>
-          <a:ln>
-            <a:noFill/>
-          </a:ln>
-        </p:spPr>
-        <p:style>
-          <a:lnRef idx="1">
-            <a:schemeClr val="accent1"/>
-          </a:lnRef>
-          <a:fillRef idx="3">
-            <a:schemeClr val="accent1"/>
-          </a:fillRef>
-          <a:effectRef idx="2">
-            <a:schemeClr val="accent1"/>
-          </a:effectRef>
-          <a:fontRef idx="minor">
-            <a:schemeClr val="lt1"/>
-          </a:fontRef>
-        </p:style>
-        <p:txBody>
-          <a:bodyPr rtlCol="0" anchor="ctr"/>
-          <a:lstStyle/>
-          <a:p>
-            <a:pPr algn="ctr"/>
-          </a:p>
-        </p:txBody>
-      </p:sp>
-      <p:sp>
-        <p:nvSpPr>
-          <p:cNvPr id="28" name="TextBox 27"/>
-          <p:cNvSpPr txBox="1"/>
-          <p:nvPr/>
-        </p:nvSpPr>
-        <p:spPr>
-          <a:xfrm>
-            <a:off x="621792" y="3794760"/>
-            <a:ext cx="2057400" cy="603504"/>
-          </a:xfrm>
-          <a:prstGeom prst="rect">
-            <a:avLst/>
-          </a:prstGeom>
-          <a:noFill/>
-        </p:spPr>
-        <p:txBody>
-          <a:bodyPr wrap="none" lIns="0" rIns="0" tIns="0" bIns="0">
-            <a:spAutoFit/>
-          </a:bodyPr>
-          <a:lstStyle/>
           <a:p>
             <a:pPr>
               <a:lnSpc>
-                <a:spcPts val="1920"/>
+                <a:spcPts val="2400"/>
               </a:lnSpc>
               <a:spcAft>
                 <a:spcPts val="0"/>
               </a:spcAft>
-              <a:defRPr sz="1600" b="0">
+              <a:defRPr sz="2000" b="0">
+                <a:solidFill>
+                  <a:srgbClr val="142E43"/>
+                </a:solidFill>
+                <a:latin typeface="DejaVu Sans"/>
+              </a:defRPr>
+            </a:pPr>
+          </a:p>
+          <a:p>
+            <a:pPr>
+              <a:lnSpc>
+                <a:spcPts val="2400"/>
+              </a:lnSpc>
+              <a:spcAft>
+                <a:spcPts val="0"/>
+              </a:spcAft>
+              <a:defRPr sz="2000" b="0">
                 <a:solidFill>
                   <a:srgbClr val="142E43"/>
                 </a:solidFill>
@@ -13835,84 +13714,18 @@
               </a:defRPr>
             </a:pPr>
             <a:r>
-              <a:t>HF validation</a:t>
+              <a:t>ρ links levels; δ is a GP correction.</a:t>
             </a:r>
           </a:p>
-        </p:txBody>
-      </p:sp>
-      <p:sp>
-        <p:nvSpPr>
-          <p:cNvPr id="29" name="Rectangle 28"/>
-          <p:cNvSpPr/>
-          <p:nvPr/>
-        </p:nvSpPr>
-        <p:spPr>
-          <a:xfrm>
-            <a:off x="2788920" y="3685032"/>
-            <a:ext cx="4174235" cy="690372"/>
-          </a:xfrm>
-          <a:prstGeom prst="rect">
-            <a:avLst/>
-          </a:prstGeom>
-          <a:solidFill>
-            <a:srgbClr val="FFFFFF"/>
-          </a:solidFill>
-          <a:ln>
-            <a:noFill/>
-          </a:ln>
-        </p:spPr>
-        <p:style>
-          <a:lnRef idx="1">
-            <a:schemeClr val="accent1"/>
-          </a:lnRef>
-          <a:fillRef idx="3">
-            <a:schemeClr val="accent1"/>
-          </a:fillRef>
-          <a:effectRef idx="2">
-            <a:schemeClr val="accent1"/>
-          </a:effectRef>
-          <a:fontRef idx="minor">
-            <a:schemeClr val="lt1"/>
-          </a:fontRef>
-        </p:style>
-        <p:txBody>
-          <a:bodyPr rtlCol="0" anchor="ctr"/>
-          <a:lstStyle/>
-          <a:p>
-            <a:pPr algn="ctr"/>
-          </a:p>
-        </p:txBody>
-      </p:sp>
-      <p:sp>
-        <p:nvSpPr>
-          <p:cNvPr id="30" name="TextBox 29"/>
-          <p:cNvSpPr txBox="1"/>
-          <p:nvPr/>
-        </p:nvSpPr>
-        <p:spPr>
-          <a:xfrm>
-            <a:off x="2907791" y="3794760"/>
-            <a:ext cx="3977639" cy="603504"/>
-          </a:xfrm>
-          <a:prstGeom prst="rect">
-            <a:avLst/>
-          </a:prstGeom>
-          <a:noFill/>
-        </p:spPr>
-        <p:txBody>
-          <a:bodyPr wrap="none" lIns="0" rIns="0" tIns="0" bIns="0">
-            <a:spAutoFit/>
-          </a:bodyPr>
-          <a:lstStyle/>
           <a:p>
             <a:pPr>
               <a:lnSpc>
-                <a:spcPts val="1920"/>
+                <a:spcPts val="2400"/>
               </a:lnSpc>
               <a:spcAft>
                 <a:spcPts val="0"/>
               </a:spcAft>
-              <a:defRPr sz="1600" b="0">
+              <a:defRPr sz="2000" b="0">
                 <a:solidFill>
                   <a:srgbClr val="142E43"/>
                 </a:solidFill>
@@ -13920,64 +13733,21 @@
               </a:defRPr>
             </a:pPr>
             <a:r>
-              <a:t>46 nonzero voxels</a:t>
+              <a:t>σₗ² is learned noise for each level.</a:t>
             </a:r>
           </a:p>
         </p:txBody>
       </p:sp>
       <p:sp>
         <p:nvSpPr>
-          <p:cNvPr id="31" name="Rectangle 30"/>
-          <p:cNvSpPr/>
-          <p:nvPr/>
-        </p:nvSpPr>
-        <p:spPr>
-          <a:xfrm>
-            <a:off x="6995159" y="3685032"/>
-            <a:ext cx="4631436" cy="690372"/>
-          </a:xfrm>
-          <a:prstGeom prst="rect">
-            <a:avLst/>
-          </a:prstGeom>
-          <a:solidFill>
-            <a:srgbClr val="FFFFFF"/>
-          </a:solidFill>
-          <a:ln>
-            <a:noFill/>
-          </a:ln>
-        </p:spPr>
-        <p:style>
-          <a:lnRef idx="1">
-            <a:schemeClr val="accent1"/>
-          </a:lnRef>
-          <a:fillRef idx="3">
-            <a:schemeClr val="accent1"/>
-          </a:fillRef>
-          <a:effectRef idx="2">
-            <a:schemeClr val="accent1"/>
-          </a:effectRef>
-          <a:fontRef idx="minor">
-            <a:schemeClr val="lt1"/>
-          </a:fontRef>
-        </p:style>
-        <p:txBody>
-          <a:bodyPr rtlCol="0" anchor="ctr"/>
-          <a:lstStyle/>
-          <a:p>
-            <a:pPr algn="ctr"/>
-          </a:p>
-        </p:txBody>
-      </p:sp>
-      <p:sp>
-        <p:nvSpPr>
-          <p:cNvPr id="32" name="TextBox 31"/>
+          <p:cNvPr id="17" name="TextBox 16"/>
           <p:cNvSpPr txBox="1"/>
           <p:nvPr/>
         </p:nvSpPr>
         <p:spPr>
           <a:xfrm>
-            <a:off x="7114031" y="3794760"/>
-            <a:ext cx="4434840" cy="603504"/>
+            <a:off x="731520" y="5148072"/>
+            <a:ext cx="10972800" cy="548640"/>
           </a:xfrm>
           <a:prstGeom prst="rect">
             <a:avLst/>
@@ -13992,282 +13762,27 @@
           <a:p>
             <a:pPr>
               <a:lnSpc>
-                <a:spcPts val="1920"/>
+                <a:spcPts val="2581"/>
               </a:lnSpc>
               <a:spcAft>
                 <a:spcPts val="0"/>
               </a:spcAft>
-              <a:defRPr sz="1600" b="0">
+              <a:defRPr sz="2151" b="1">
                 <a:solidFill>
-                  <a:srgbClr val="142E43"/>
+                  <a:srgbClr val="007F83"/>
                 </a:solidFill>
                 <a:latin typeface="DejaVu Sans"/>
               </a:defRPr>
             </a:pPr>
             <a:r>
-              <a:t>55 voxels, including 8 zero-hit</a:t>
+              <a:t>Three log-space outputs: LF CNP mean • HF CNP mean • HF raw rate*</a:t>
             </a:r>
           </a:p>
         </p:txBody>
       </p:sp>
       <p:sp>
         <p:nvSpPr>
-          <p:cNvPr id="33" name="Rectangle 32"/>
-          <p:cNvSpPr/>
-          <p:nvPr/>
-        </p:nvSpPr>
-        <p:spPr>
-          <a:xfrm>
-            <a:off x="502920" y="4398264"/>
-            <a:ext cx="2253996" cy="690372"/>
-          </a:xfrm>
-          <a:prstGeom prst="rect">
-            <a:avLst/>
-          </a:prstGeom>
-          <a:solidFill>
-            <a:srgbClr val="E8EFF3"/>
-          </a:solidFill>
-          <a:ln>
-            <a:noFill/>
-          </a:ln>
-        </p:spPr>
-        <p:style>
-          <a:lnRef idx="1">
-            <a:schemeClr val="accent1"/>
-          </a:lnRef>
-          <a:fillRef idx="3">
-            <a:schemeClr val="accent1"/>
-          </a:fillRef>
-          <a:effectRef idx="2">
-            <a:schemeClr val="accent1"/>
-          </a:effectRef>
-          <a:fontRef idx="minor">
-            <a:schemeClr val="lt1"/>
-          </a:fontRef>
-        </p:style>
-        <p:txBody>
-          <a:bodyPr rtlCol="0" anchor="ctr"/>
-          <a:lstStyle/>
-          <a:p>
-            <a:pPr algn="ctr"/>
-          </a:p>
-        </p:txBody>
-      </p:sp>
-      <p:sp>
-        <p:nvSpPr>
-          <p:cNvPr id="34" name="TextBox 33"/>
-          <p:cNvSpPr txBox="1"/>
-          <p:nvPr/>
-        </p:nvSpPr>
-        <p:spPr>
-          <a:xfrm>
-            <a:off x="621792" y="4507992"/>
-            <a:ext cx="2057400" cy="603504"/>
-          </a:xfrm>
-          <a:prstGeom prst="rect">
-            <a:avLst/>
-          </a:prstGeom>
-          <a:noFill/>
-        </p:spPr>
-        <p:txBody>
-          <a:bodyPr wrap="none" lIns="0" rIns="0" tIns="0" bIns="0">
-            <a:spAutoFit/>
-          </a:bodyPr>
-          <a:lstStyle/>
-          <a:p>
-            <a:pPr>
-              <a:lnSpc>
-                <a:spcPts val="1920"/>
-              </a:lnSpc>
-              <a:spcAft>
-                <a:spcPts val="0"/>
-              </a:spcAft>
-              <a:defRPr sz="1600" b="0">
-                <a:solidFill>
-                  <a:srgbClr val="142E43"/>
-                </a:solidFill>
-                <a:latin typeface="DejaVu Sans"/>
-              </a:defRPr>
-            </a:pPr>
-            <a:r>
-              <a:t>HF primary budget</a:t>
-            </a:r>
-          </a:p>
-        </p:txBody>
-      </p:sp>
-      <p:sp>
-        <p:nvSpPr>
-          <p:cNvPr id="35" name="Rectangle 34"/>
-          <p:cNvSpPr/>
-          <p:nvPr/>
-        </p:nvSpPr>
-        <p:spPr>
-          <a:xfrm>
-            <a:off x="2788920" y="4398264"/>
-            <a:ext cx="4174235" cy="690372"/>
-          </a:xfrm>
-          <a:prstGeom prst="rect">
-            <a:avLst/>
-          </a:prstGeom>
-          <a:solidFill>
-            <a:srgbClr val="E8EFF3"/>
-          </a:solidFill>
-          <a:ln>
-            <a:noFill/>
-          </a:ln>
-        </p:spPr>
-        <p:style>
-          <a:lnRef idx="1">
-            <a:schemeClr val="accent1"/>
-          </a:lnRef>
-          <a:fillRef idx="3">
-            <a:schemeClr val="accent1"/>
-          </a:fillRef>
-          <a:effectRef idx="2">
-            <a:schemeClr val="accent1"/>
-          </a:effectRef>
-          <a:fontRef idx="minor">
-            <a:schemeClr val="lt1"/>
-          </a:fontRef>
-        </p:style>
-        <p:txBody>
-          <a:bodyPr rtlCol="0" anchor="ctr"/>
-          <a:lstStyle/>
-          <a:p>
-            <a:pPr algn="ctr"/>
-          </a:p>
-        </p:txBody>
-      </p:sp>
-      <p:sp>
-        <p:nvSpPr>
-          <p:cNvPr id="36" name="TextBox 35"/>
-          <p:cNvSpPr txBox="1"/>
-          <p:nvPr/>
-        </p:nvSpPr>
-        <p:spPr>
-          <a:xfrm>
-            <a:off x="2907791" y="4507992"/>
-            <a:ext cx="3977639" cy="603504"/>
-          </a:xfrm>
-          <a:prstGeom prst="rect">
-            <a:avLst/>
-          </a:prstGeom>
-          <a:noFill/>
-        </p:spPr>
-        <p:txBody>
-          <a:bodyPr wrap="none" lIns="0" rIns="0" tIns="0" bIns="0">
-            <a:spAutoFit/>
-          </a:bodyPr>
-          <a:lstStyle/>
-          <a:p>
-            <a:pPr>
-              <a:lnSpc>
-                <a:spcPts val="1920"/>
-              </a:lnSpc>
-              <a:spcAft>
-                <a:spcPts val="0"/>
-              </a:spcAft>
-              <a:defRPr sz="1600" b="0">
-                <a:solidFill>
-                  <a:srgbClr val="142E43"/>
-                </a:solidFill>
-                <a:latin typeface="DejaVu Sans"/>
-              </a:defRPr>
-            </a:pPr>
-            <a:r>
-              <a:t>4936 after context removal</a:t>
-            </a:r>
-          </a:p>
-        </p:txBody>
-      </p:sp>
-      <p:sp>
-        <p:nvSpPr>
-          <p:cNvPr id="37" name="Rectangle 36"/>
-          <p:cNvSpPr/>
-          <p:nvPr/>
-        </p:nvSpPr>
-        <p:spPr>
-          <a:xfrm>
-            <a:off x="6995159" y="4398264"/>
-            <a:ext cx="4631436" cy="690372"/>
-          </a:xfrm>
-          <a:prstGeom prst="rect">
-            <a:avLst/>
-          </a:prstGeom>
-          <a:solidFill>
-            <a:srgbClr val="E8EFF3"/>
-          </a:solidFill>
-          <a:ln>
-            <a:noFill/>
-          </a:ln>
-        </p:spPr>
-        <p:style>
-          <a:lnRef idx="1">
-            <a:schemeClr val="accent1"/>
-          </a:lnRef>
-          <a:fillRef idx="3">
-            <a:schemeClr val="accent1"/>
-          </a:fillRef>
-          <a:effectRef idx="2">
-            <a:schemeClr val="accent1"/>
-          </a:effectRef>
-          <a:fontRef idx="minor">
-            <a:schemeClr val="lt1"/>
-          </a:fontRef>
-        </p:style>
-        <p:txBody>
-          <a:bodyPr rtlCol="0" anchor="ctr"/>
-          <a:lstStyle/>
-          <a:p>
-            <a:pPr algn="ctr"/>
-          </a:p>
-        </p:txBody>
-      </p:sp>
-      <p:sp>
-        <p:nvSpPr>
-          <p:cNvPr id="38" name="TextBox 37"/>
-          <p:cNvSpPr txBox="1"/>
-          <p:nvPr/>
-        </p:nvSpPr>
-        <p:spPr>
-          <a:xfrm>
-            <a:off x="7114031" y="4507992"/>
-            <a:ext cx="4434840" cy="603504"/>
-          </a:xfrm>
-          <a:prstGeom prst="rect">
-            <a:avLst/>
-          </a:prstGeom>
-          <a:noFill/>
-        </p:spPr>
-        <p:txBody>
-          <a:bodyPr wrap="none" lIns="0" rIns="0" tIns="0" bIns="0">
-            <a:spAutoFit/>
-          </a:bodyPr>
-          <a:lstStyle/>
-          <a:p>
-            <a:pPr>
-              <a:lnSpc>
-                <a:spcPts val="1920"/>
-              </a:lnSpc>
-              <a:spcAft>
-                <a:spcPts val="0"/>
-              </a:spcAft>
-              <a:defRPr sz="1600" b="0">
-                <a:solidFill>
-                  <a:srgbClr val="142E43"/>
-                </a:solidFill>
-                <a:latin typeface="DejaVu Sans"/>
-              </a:defRPr>
-            </a:pPr>
-            <a:r>
-              <a:t>Full 5000</a:t>
-            </a:r>
-          </a:p>
-        </p:txBody>
-      </p:sp>
-      <p:sp>
-        <p:nvSpPr>
-          <p:cNvPr id="39" name="TextBox 38"/>
+          <p:cNvPr id="18" name="TextBox 17"/>
           <p:cNvSpPr txBox="1"/>
           <p:nvPr/>
         </p:nvSpPr>
@@ -14302,7 +13817,7 @@
               </a:defRPr>
             </a:pPr>
             <a:r>
-              <a:t>Different data and targets can change results independently of the modeling approach.</a:t>
+              <a:t>* HF training rates are smoothed before taking logs. The MFGP likelihood is Gaussian, not binomial.</a:t>
             </a:r>
           </a:p>
         </p:txBody>
@@ -14448,6 +13963,2486 @@
               </a:defRPr>
             </a:pPr>
             <a:r>
+              <a:t>APPENDIX • EQUATIONS</a:t>
+            </a:r>
+          </a:p>
+        </p:txBody>
+      </p:sp>
+      <p:sp>
+        <p:nvSpPr>
+          <p:cNvPr id="5" name="TextBox 4"/>
+          <p:cNvSpPr txBox="1"/>
+          <p:nvPr/>
+        </p:nvSpPr>
+        <p:spPr>
+          <a:xfrm>
+            <a:off x="502920" y="777240"/>
+            <a:ext cx="11247120" cy="731520"/>
+          </a:xfrm>
+          <a:prstGeom prst="rect">
+            <a:avLst/>
+          </a:prstGeom>
+          <a:noFill/>
+        </p:spPr>
+        <p:txBody>
+          <a:bodyPr wrap="none" lIns="0" rIns="0" tIns="0" bIns="0">
+            <a:spAutoFit/>
+          </a:bodyPr>
+          <a:lstStyle/>
+          <a:p>
+            <a:pPr>
+              <a:lnSpc>
+                <a:spcPts val="3166"/>
+              </a:lnSpc>
+              <a:spcAft>
+                <a:spcPts val="0"/>
+              </a:spcAft>
+              <a:defRPr sz="2638" b="1">
+                <a:solidFill>
+                  <a:srgbClr val="142E43"/>
+                </a:solidFill>
+                <a:latin typeface="DejaVu Sans"/>
+              </a:defRPr>
+            </a:pPr>
+            <a:r>
+              <a:t>Technical appendix: probability and counting uncertainty</a:t>
+            </a:r>
+          </a:p>
+        </p:txBody>
+      </p:sp>
+      <p:sp>
+        <p:nvSpPr>
+          <p:cNvPr id="6" name="Rectangle 5"/>
+          <p:cNvSpPr/>
+          <p:nvPr/>
+        </p:nvSpPr>
+        <p:spPr>
+          <a:xfrm>
+            <a:off x="502920" y="6364224"/>
+            <a:ext cx="11155680" cy="13716"/>
+          </a:xfrm>
+          <a:prstGeom prst="rect">
+            <a:avLst/>
+          </a:prstGeom>
+          <a:solidFill>
+            <a:srgbClr val="D6E0E7"/>
+          </a:solidFill>
+          <a:ln>
+            <a:noFill/>
+          </a:ln>
+        </p:spPr>
+        <p:style>
+          <a:lnRef idx="1">
+            <a:schemeClr val="accent1"/>
+          </a:lnRef>
+          <a:fillRef idx="3">
+            <a:schemeClr val="accent1"/>
+          </a:fillRef>
+          <a:effectRef idx="2">
+            <a:schemeClr val="accent1"/>
+          </a:effectRef>
+          <a:fontRef idx="minor">
+            <a:schemeClr val="lt1"/>
+          </a:fontRef>
+        </p:style>
+        <p:txBody>
+          <a:bodyPr rtlCol="0" anchor="ctr"/>
+          <a:lstStyle/>
+          <a:p>
+            <a:pPr algn="ctr"/>
+          </a:p>
+        </p:txBody>
+      </p:sp>
+      <p:sp>
+        <p:nvSpPr>
+          <p:cNvPr id="7" name="TextBox 6"/>
+          <p:cNvSpPr txBox="1"/>
+          <p:nvPr/>
+        </p:nvSpPr>
+        <p:spPr>
+          <a:xfrm>
+            <a:off x="502920" y="6492240"/>
+            <a:ext cx="9144000" cy="201168"/>
+          </a:xfrm>
+          <a:prstGeom prst="rect">
+            <a:avLst/>
+          </a:prstGeom>
+          <a:noFill/>
+        </p:spPr>
+        <p:txBody>
+          <a:bodyPr wrap="none" lIns="0" rIns="0" tIns="0" bIns="0">
+            <a:spAutoFit/>
+          </a:bodyPr>
+          <a:lstStyle/>
+          <a:p>
+            <a:pPr>
+              <a:lnSpc>
+                <a:spcPts val="1200"/>
+              </a:lnSpc>
+              <a:spcAft>
+                <a:spcPts val="0"/>
+              </a:spcAft>
+              <a:defRPr sz="1000" b="0">
+                <a:solidFill>
+                  <a:srgbClr val="536777"/>
+                </a:solidFill>
+                <a:latin typeface="DejaVu Sans"/>
+              </a:defRPr>
+            </a:pPr>
+            <a:r>
+              <a:t>LAr optical map • From simulated events to detection probability</a:t>
+            </a:r>
+          </a:p>
+        </p:txBody>
+      </p:sp>
+      <p:sp>
+        <p:nvSpPr>
+          <p:cNvPr id="8" name="TextBox 7"/>
+          <p:cNvSpPr txBox="1"/>
+          <p:nvPr/>
+        </p:nvSpPr>
+        <p:spPr>
+          <a:xfrm>
+            <a:off x="11201400" y="6492240"/>
+            <a:ext cx="457200" cy="201168"/>
+          </a:xfrm>
+          <a:prstGeom prst="rect">
+            <a:avLst/>
+          </a:prstGeom>
+          <a:noFill/>
+        </p:spPr>
+        <p:txBody>
+          <a:bodyPr wrap="none" lIns="0" rIns="0" tIns="0" bIns="0">
+            <a:spAutoFit/>
+          </a:bodyPr>
+          <a:lstStyle/>
+          <a:p>
+            <a:pPr>
+              <a:lnSpc>
+                <a:spcPts val="1200"/>
+              </a:lnSpc>
+              <a:spcAft>
+                <a:spcPts val="0"/>
+              </a:spcAft>
+              <a:defRPr sz="1000" b="0">
+                <a:solidFill>
+                  <a:srgbClr val="536777"/>
+                </a:solidFill>
+                <a:latin typeface="DejaVu Sans"/>
+              </a:defRPr>
+            </a:pPr>
+            <a:r>
+              <a:t>15</a:t>
+            </a:r>
+          </a:p>
+        </p:txBody>
+      </p:sp>
+      <p:sp>
+        <p:nvSpPr>
+          <p:cNvPr id="9" name="Rectangle 8"/>
+          <p:cNvSpPr/>
+          <p:nvPr/>
+        </p:nvSpPr>
+        <p:spPr>
+          <a:xfrm>
+            <a:off x="594360" y="1737360"/>
+            <a:ext cx="5486400" cy="1965960"/>
+          </a:xfrm>
+          <a:prstGeom prst="rect">
+            <a:avLst/>
+          </a:prstGeom>
+          <a:solidFill>
+            <a:srgbClr val="FFFFFF"/>
+          </a:solidFill>
+          <a:ln>
+            <a:noFill/>
+          </a:ln>
+        </p:spPr>
+        <p:style>
+          <a:lnRef idx="1">
+            <a:schemeClr val="accent1"/>
+          </a:lnRef>
+          <a:fillRef idx="3">
+            <a:schemeClr val="accent1"/>
+          </a:fillRef>
+          <a:effectRef idx="2">
+            <a:schemeClr val="accent1"/>
+          </a:effectRef>
+          <a:fontRef idx="minor">
+            <a:schemeClr val="lt1"/>
+          </a:fontRef>
+        </p:style>
+        <p:txBody>
+          <a:bodyPr rtlCol="0" anchor="ctr"/>
+          <a:lstStyle/>
+          <a:p>
+            <a:pPr algn="ctr"/>
+          </a:p>
+        </p:txBody>
+      </p:sp>
+      <p:sp>
+        <p:nvSpPr>
+          <p:cNvPr id="10" name="Rectangle 9"/>
+          <p:cNvSpPr/>
+          <p:nvPr/>
+        </p:nvSpPr>
+        <p:spPr>
+          <a:xfrm>
+            <a:off x="594360" y="1737360"/>
+            <a:ext cx="64008" cy="1965960"/>
+          </a:xfrm>
+          <a:prstGeom prst="rect">
+            <a:avLst/>
+          </a:prstGeom>
+          <a:solidFill>
+            <a:srgbClr val="007F83"/>
+          </a:solidFill>
+          <a:ln>
+            <a:noFill/>
+          </a:ln>
+        </p:spPr>
+        <p:style>
+          <a:lnRef idx="1">
+            <a:schemeClr val="accent1"/>
+          </a:lnRef>
+          <a:fillRef idx="3">
+            <a:schemeClr val="accent1"/>
+          </a:fillRef>
+          <a:effectRef idx="2">
+            <a:schemeClr val="accent1"/>
+          </a:effectRef>
+          <a:fontRef idx="minor">
+            <a:schemeClr val="lt1"/>
+          </a:fontRef>
+        </p:style>
+        <p:txBody>
+          <a:bodyPr rtlCol="0" anchor="ctr"/>
+          <a:lstStyle/>
+          <a:p>
+            <a:pPr algn="ctr"/>
+          </a:p>
+        </p:txBody>
+      </p:sp>
+      <p:sp>
+        <p:nvSpPr>
+          <p:cNvPr id="11" name="TextBox 10"/>
+          <p:cNvSpPr txBox="1"/>
+          <p:nvPr/>
+        </p:nvSpPr>
+        <p:spPr>
+          <a:xfrm>
+            <a:off x="822960" y="1938528"/>
+            <a:ext cx="5029200" cy="457200"/>
+          </a:xfrm>
+          <a:prstGeom prst="rect">
+            <a:avLst/>
+          </a:prstGeom>
+          <a:noFill/>
+        </p:spPr>
+        <p:txBody>
+          <a:bodyPr wrap="none" lIns="0" rIns="0" tIns="0" bIns="0">
+            <a:spAutoFit/>
+          </a:bodyPr>
+          <a:lstStyle/>
+          <a:p>
+            <a:pPr>
+              <a:lnSpc>
+                <a:spcPts val="2760"/>
+              </a:lnSpc>
+              <a:spcAft>
+                <a:spcPts val="0"/>
+              </a:spcAft>
+              <a:defRPr sz="2300" b="1">
+                <a:solidFill>
+                  <a:srgbClr val="007F83"/>
+                </a:solidFill>
+                <a:latin typeface="DejaVu Sans"/>
+              </a:defRPr>
+            </a:pPr>
+            <a:r>
+              <a:t>1 Spatial pattern</a:t>
+            </a:r>
+          </a:p>
+        </p:txBody>
+      </p:sp>
+      <p:sp>
+        <p:nvSpPr>
+          <p:cNvPr id="12" name="TextBox 11"/>
+          <p:cNvSpPr txBox="1"/>
+          <p:nvPr/>
+        </p:nvSpPr>
+        <p:spPr>
+          <a:xfrm>
+            <a:off x="822960" y="2578608"/>
+            <a:ext cx="5029200" cy="1097280"/>
+          </a:xfrm>
+          <a:prstGeom prst="rect">
+            <a:avLst/>
+          </a:prstGeom>
+          <a:noFill/>
+        </p:spPr>
+        <p:txBody>
+          <a:bodyPr wrap="none" lIns="0" rIns="0" tIns="0" bIns="0">
+            <a:spAutoFit/>
+          </a:bodyPr>
+          <a:lstStyle/>
+          <a:p>
+            <a:pPr>
+              <a:lnSpc>
+                <a:spcPts val="2400"/>
+              </a:lnSpc>
+              <a:spcAft>
+                <a:spcPts val="0"/>
+              </a:spcAft>
+              <a:defRPr sz="2000" b="0">
+                <a:solidFill>
+                  <a:srgbClr val="142E43"/>
+                </a:solidFill>
+                <a:latin typeface="DejaVu Sans"/>
+              </a:defRPr>
+            </a:pPr>
+            <a:r>
+              <a:t>f(s) ~ GP(0, k)</a:t>
+            </a:r>
+          </a:p>
+          <a:p>
+            <a:pPr>
+              <a:lnSpc>
+                <a:spcPts val="2400"/>
+              </a:lnSpc>
+              <a:spcAft>
+                <a:spcPts val="0"/>
+              </a:spcAft>
+              <a:defRPr sz="2000" b="0">
+                <a:solidFill>
+                  <a:srgbClr val="142E43"/>
+                </a:solidFill>
+                <a:latin typeface="DejaVu Sans"/>
+              </a:defRPr>
+            </a:pPr>
+          </a:p>
+          <a:p>
+            <a:pPr>
+              <a:lnSpc>
+                <a:spcPts val="2400"/>
+              </a:lnSpc>
+              <a:spcAft>
+                <a:spcPts val="0"/>
+              </a:spcAft>
+              <a:defRPr sz="2000" b="0">
+                <a:solidFill>
+                  <a:srgbClr val="142E43"/>
+                </a:solidFill>
+                <a:latin typeface="DejaVu Sans"/>
+              </a:defRPr>
+            </a:pPr>
+            <a:r>
+              <a:t>p(s) = 1 / [1 + exp(−f(s))]</a:t>
+            </a:r>
+          </a:p>
+        </p:txBody>
+      </p:sp>
+      <p:sp>
+        <p:nvSpPr>
+          <p:cNvPr id="13" name="Rectangle 12"/>
+          <p:cNvSpPr/>
+          <p:nvPr/>
+        </p:nvSpPr>
+        <p:spPr>
+          <a:xfrm>
+            <a:off x="6263640" y="1737360"/>
+            <a:ext cx="5303520" cy="1965960"/>
+          </a:xfrm>
+          <a:prstGeom prst="rect">
+            <a:avLst/>
+          </a:prstGeom>
+          <a:solidFill>
+            <a:srgbClr val="FFFFFF"/>
+          </a:solidFill>
+          <a:ln>
+            <a:noFill/>
+          </a:ln>
+        </p:spPr>
+        <p:style>
+          <a:lnRef idx="1">
+            <a:schemeClr val="accent1"/>
+          </a:lnRef>
+          <a:fillRef idx="3">
+            <a:schemeClr val="accent1"/>
+          </a:fillRef>
+          <a:effectRef idx="2">
+            <a:schemeClr val="accent1"/>
+          </a:effectRef>
+          <a:fontRef idx="minor">
+            <a:schemeClr val="lt1"/>
+          </a:fontRef>
+        </p:style>
+        <p:txBody>
+          <a:bodyPr rtlCol="0" anchor="ctr"/>
+          <a:lstStyle/>
+          <a:p>
+            <a:pPr algn="ctr"/>
+          </a:p>
+        </p:txBody>
+      </p:sp>
+      <p:sp>
+        <p:nvSpPr>
+          <p:cNvPr id="14" name="Rectangle 13"/>
+          <p:cNvSpPr/>
+          <p:nvPr/>
+        </p:nvSpPr>
+        <p:spPr>
+          <a:xfrm>
+            <a:off x="6263640" y="1737360"/>
+            <a:ext cx="64008" cy="1965960"/>
+          </a:xfrm>
+          <a:prstGeom prst="rect">
+            <a:avLst/>
+          </a:prstGeom>
+          <a:solidFill>
+            <a:srgbClr val="007F83"/>
+          </a:solidFill>
+          <a:ln>
+            <a:noFill/>
+          </a:ln>
+        </p:spPr>
+        <p:style>
+          <a:lnRef idx="1">
+            <a:schemeClr val="accent1"/>
+          </a:lnRef>
+          <a:fillRef idx="3">
+            <a:schemeClr val="accent1"/>
+          </a:fillRef>
+          <a:effectRef idx="2">
+            <a:schemeClr val="accent1"/>
+          </a:effectRef>
+          <a:fontRef idx="minor">
+            <a:schemeClr val="lt1"/>
+          </a:fontRef>
+        </p:style>
+        <p:txBody>
+          <a:bodyPr rtlCol="0" anchor="ctr"/>
+          <a:lstStyle/>
+          <a:p>
+            <a:pPr algn="ctr"/>
+          </a:p>
+        </p:txBody>
+      </p:sp>
+      <p:sp>
+        <p:nvSpPr>
+          <p:cNvPr id="15" name="TextBox 14"/>
+          <p:cNvSpPr txBox="1"/>
+          <p:nvPr/>
+        </p:nvSpPr>
+        <p:spPr>
+          <a:xfrm>
+            <a:off x="6492240" y="1938528"/>
+            <a:ext cx="4846320" cy="457200"/>
+          </a:xfrm>
+          <a:prstGeom prst="rect">
+            <a:avLst/>
+          </a:prstGeom>
+          <a:noFill/>
+        </p:spPr>
+        <p:txBody>
+          <a:bodyPr wrap="none" lIns="0" rIns="0" tIns="0" bIns="0">
+            <a:spAutoFit/>
+          </a:bodyPr>
+          <a:lstStyle/>
+          <a:p>
+            <a:pPr>
+              <a:lnSpc>
+                <a:spcPts val="2760"/>
+              </a:lnSpc>
+              <a:spcAft>
+                <a:spcPts val="0"/>
+              </a:spcAft>
+              <a:defRPr sz="2300" b="1">
+                <a:solidFill>
+                  <a:srgbClr val="007F83"/>
+                </a:solidFill>
+                <a:latin typeface="DejaVu Sans"/>
+              </a:defRPr>
+            </a:pPr>
+            <a:r>
+              <a:t>2 Counts at each voxel</a:t>
+            </a:r>
+          </a:p>
+        </p:txBody>
+      </p:sp>
+      <p:sp>
+        <p:nvSpPr>
+          <p:cNvPr id="16" name="TextBox 15"/>
+          <p:cNvSpPr txBox="1"/>
+          <p:nvPr/>
+        </p:nvSpPr>
+        <p:spPr>
+          <a:xfrm>
+            <a:off x="6492240" y="2578608"/>
+            <a:ext cx="4846320" cy="1097280"/>
+          </a:xfrm>
+          <a:prstGeom prst="rect">
+            <a:avLst/>
+          </a:prstGeom>
+          <a:noFill/>
+        </p:spPr>
+        <p:txBody>
+          <a:bodyPr wrap="none" lIns="0" rIns="0" tIns="0" bIns="0">
+            <a:spAutoFit/>
+          </a:bodyPr>
+          <a:lstStyle/>
+          <a:p>
+            <a:pPr>
+              <a:lnSpc>
+                <a:spcPts val="2400"/>
+              </a:lnSpc>
+              <a:spcAft>
+                <a:spcPts val="0"/>
+              </a:spcAft>
+              <a:defRPr sz="2000" b="0">
+                <a:solidFill>
+                  <a:srgbClr val="142E43"/>
+                </a:solidFill>
+                <a:latin typeface="DejaVu Sans"/>
+              </a:defRPr>
+            </a:pPr>
+            <a:r>
+              <a:t>mᵢ ~ Binomial(Nᵢ, p(sᵢ))</a:t>
+            </a:r>
+          </a:p>
+          <a:p>
+            <a:pPr>
+              <a:lnSpc>
+                <a:spcPts val="2400"/>
+              </a:lnSpc>
+              <a:spcAft>
+                <a:spcPts val="0"/>
+              </a:spcAft>
+              <a:defRPr sz="2000" b="0">
+                <a:solidFill>
+                  <a:srgbClr val="142E43"/>
+                </a:solidFill>
+                <a:latin typeface="DejaVu Sans"/>
+              </a:defRPr>
+            </a:pPr>
+          </a:p>
+          <a:p>
+            <a:pPr>
+              <a:lnSpc>
+                <a:spcPts val="2400"/>
+              </a:lnSpc>
+              <a:spcAft>
+                <a:spcPts val="0"/>
+              </a:spcAft>
+              <a:defRPr sz="2000" b="0">
+                <a:solidFill>
+                  <a:srgbClr val="142E43"/>
+                </a:solidFill>
+                <a:latin typeface="DejaVu Sans"/>
+              </a:defRPr>
+            </a:pPr>
+            <a:r>
+              <a:t>Nᵢ is known; p(sᵢ) is inferred.</a:t>
+            </a:r>
+          </a:p>
+        </p:txBody>
+      </p:sp>
+      <p:sp>
+        <p:nvSpPr>
+          <p:cNvPr id="17" name="TextBox 16"/>
+          <p:cNvSpPr txBox="1"/>
+          <p:nvPr/>
+        </p:nvSpPr>
+        <p:spPr>
+          <a:xfrm>
+            <a:off x="777240" y="4206240"/>
+            <a:ext cx="10515600" cy="457200"/>
+          </a:xfrm>
+          <a:prstGeom prst="rect">
+            <a:avLst/>
+          </a:prstGeom>
+          <a:noFill/>
+        </p:spPr>
+        <p:txBody>
+          <a:bodyPr wrap="none" lIns="0" rIns="0" tIns="0" bIns="0">
+            <a:spAutoFit/>
+          </a:bodyPr>
+          <a:lstStyle/>
+          <a:p>
+            <a:pPr>
+              <a:lnSpc>
+                <a:spcPts val="2879"/>
+              </a:lnSpc>
+              <a:spcAft>
+                <a:spcPts val="0"/>
+              </a:spcAft>
+              <a:defRPr sz="2400" b="1">
+                <a:solidFill>
+                  <a:srgbClr val="142E43"/>
+                </a:solidFill>
+                <a:latin typeface="DejaVu Sans"/>
+              </a:defRPr>
+            </a:pPr>
+            <a:r>
+              <a:t>Predicted fraction variance at an exact location:</a:t>
+            </a:r>
+          </a:p>
+        </p:txBody>
+      </p:sp>
+      <p:sp>
+        <p:nvSpPr>
+          <p:cNvPr id="18" name="TextBox 17"/>
+          <p:cNvSpPr txBox="1"/>
+          <p:nvPr/>
+        </p:nvSpPr>
+        <p:spPr>
+          <a:xfrm>
+            <a:off x="777240" y="4846320"/>
+            <a:ext cx="10515600" cy="731520"/>
+          </a:xfrm>
+          <a:prstGeom prst="rect">
+            <a:avLst/>
+          </a:prstGeom>
+          <a:noFill/>
+        </p:spPr>
+        <p:txBody>
+          <a:bodyPr wrap="none" lIns="0" rIns="0" tIns="0" bIns="0">
+            <a:spAutoFit/>
+          </a:bodyPr>
+          <a:lstStyle/>
+          <a:p>
+            <a:pPr>
+              <a:lnSpc>
+                <a:spcPts val="2879"/>
+              </a:lnSpc>
+              <a:spcAft>
+                <a:spcPts val="0"/>
+              </a:spcAft>
+              <a:defRPr sz="2400" b="0">
+                <a:solidFill>
+                  <a:srgbClr val="007F83"/>
+                </a:solidFill>
+                <a:latin typeface="DejaVu Sans"/>
+              </a:defRPr>
+            </a:pPr>
+            <a:r>
+              <a:t>Var(R | s, D) = Var(P | s, D) + E[P(1 − P) | s, D] / N</a:t>
+            </a:r>
+          </a:p>
+        </p:txBody>
+      </p:sp>
+      <p:sp>
+        <p:nvSpPr>
+          <p:cNvPr id="19" name="TextBox 18"/>
+          <p:cNvSpPr txBox="1"/>
+          <p:nvPr/>
+        </p:nvSpPr>
+        <p:spPr>
+          <a:xfrm>
+            <a:off x="594360" y="5852160"/>
+            <a:ext cx="10972800" cy="411480"/>
+          </a:xfrm>
+          <a:prstGeom prst="rect">
+            <a:avLst/>
+          </a:prstGeom>
+          <a:noFill/>
+        </p:spPr>
+        <p:txBody>
+          <a:bodyPr wrap="none" lIns="0" rIns="0" tIns="0" bIns="0">
+            <a:spAutoFit/>
+          </a:bodyPr>
+          <a:lstStyle/>
+          <a:p>
+            <a:pPr>
+              <a:lnSpc>
+                <a:spcPts val="1800"/>
+              </a:lnSpc>
+              <a:spcAft>
+                <a:spcPts val="0"/>
+              </a:spcAft>
+              <a:defRPr sz="1500" b="0">
+                <a:solidFill>
+                  <a:srgbClr val="536777"/>
+                </a:solidFill>
+                <a:latin typeface="DejaVu Sans"/>
+              </a:defRPr>
+            </a:pPr>
+            <a:r>
+              <a:t>First term: uncertainty in the map. Second term: counting noise. Inference uses a Laplace approximation.</a:t>
+            </a:r>
+          </a:p>
+        </p:txBody>
+      </p:sp>
+    </p:spTree>
+  </p:cSld>
+  <p:clrMapOvr>
+    <a:masterClrMapping/>
+  </p:clrMapOvr>
+</p:sld>
+</file>
+
+<file path=ppt/slides/slide16.xml><?xml version="1.0" encoding="utf-8"?>
+<p:sld xmlns:a="http://schemas.openxmlformats.org/drawingml/2006/main" xmlns:p="http://schemas.openxmlformats.org/presentationml/2006/main" xmlns:r="http://schemas.openxmlformats.org/officeDocument/2006/relationships">
+  <p:cSld>
+    <p:spTree>
+      <p:nvGrpSpPr>
+        <p:cNvPr id="1" name=""/>
+        <p:cNvGrpSpPr/>
+        <p:nvPr/>
+      </p:nvGrpSpPr>
+      <p:grpSpPr/>
+      <p:sp>
+        <p:nvSpPr>
+          <p:cNvPr id="2" name="Rectangle 1"/>
+          <p:cNvSpPr/>
+          <p:nvPr/>
+        </p:nvSpPr>
+        <p:spPr>
+          <a:xfrm>
+            <a:off x="0" y="0"/>
+            <a:ext cx="12191695" cy="6858000"/>
+          </a:xfrm>
+          <a:prstGeom prst="rect">
+            <a:avLst/>
+          </a:prstGeom>
+          <a:solidFill>
+            <a:srgbClr val="F4F7FA"/>
+          </a:solidFill>
+          <a:ln>
+            <a:noFill/>
+          </a:ln>
+        </p:spPr>
+        <p:style>
+          <a:lnRef idx="1">
+            <a:schemeClr val="accent1"/>
+          </a:lnRef>
+          <a:fillRef idx="3">
+            <a:schemeClr val="accent1"/>
+          </a:fillRef>
+          <a:effectRef idx="2">
+            <a:schemeClr val="accent1"/>
+          </a:effectRef>
+          <a:fontRef idx="minor">
+            <a:schemeClr val="lt1"/>
+          </a:fontRef>
+        </p:style>
+        <p:txBody>
+          <a:bodyPr rtlCol="0" anchor="ctr"/>
+          <a:lstStyle/>
+          <a:p>
+            <a:pPr algn="ctr"/>
+          </a:p>
+        </p:txBody>
+      </p:sp>
+      <p:sp>
+        <p:nvSpPr>
+          <p:cNvPr id="3" name="Rectangle 2"/>
+          <p:cNvSpPr/>
+          <p:nvPr/>
+        </p:nvSpPr>
+        <p:spPr>
+          <a:xfrm>
+            <a:off x="0" y="0"/>
+            <a:ext cx="12191695" cy="100584"/>
+          </a:xfrm>
+          <a:prstGeom prst="rect">
+            <a:avLst/>
+          </a:prstGeom>
+          <a:solidFill>
+            <a:srgbClr val="007F83"/>
+          </a:solidFill>
+          <a:ln>
+            <a:noFill/>
+          </a:ln>
+        </p:spPr>
+        <p:style>
+          <a:lnRef idx="1">
+            <a:schemeClr val="accent1"/>
+          </a:lnRef>
+          <a:fillRef idx="3">
+            <a:schemeClr val="accent1"/>
+          </a:fillRef>
+          <a:effectRef idx="2">
+            <a:schemeClr val="accent1"/>
+          </a:effectRef>
+          <a:fontRef idx="minor">
+            <a:schemeClr val="lt1"/>
+          </a:fontRef>
+        </p:style>
+        <p:txBody>
+          <a:bodyPr rtlCol="0" anchor="ctr"/>
+          <a:lstStyle/>
+          <a:p>
+            <a:pPr algn="ctr"/>
+          </a:p>
+        </p:txBody>
+      </p:sp>
+      <p:sp>
+        <p:nvSpPr>
+          <p:cNvPr id="4" name="TextBox 3"/>
+          <p:cNvSpPr txBox="1"/>
+          <p:nvPr/>
+        </p:nvSpPr>
+        <p:spPr>
+          <a:xfrm>
+            <a:off x="502920" y="301752"/>
+            <a:ext cx="10972800" cy="274320"/>
+          </a:xfrm>
+          <a:prstGeom prst="rect">
+            <a:avLst/>
+          </a:prstGeom>
+          <a:noFill/>
+        </p:spPr>
+        <p:txBody>
+          <a:bodyPr wrap="none" lIns="0" rIns="0" tIns="0" bIns="0">
+            <a:spAutoFit/>
+          </a:bodyPr>
+          <a:lstStyle/>
+          <a:p>
+            <a:pPr>
+              <a:lnSpc>
+                <a:spcPts val="1439"/>
+              </a:lnSpc>
+              <a:spcAft>
+                <a:spcPts val="0"/>
+              </a:spcAft>
+              <a:defRPr sz="1200" b="1">
+                <a:solidFill>
+                  <a:srgbClr val="007F83"/>
+                </a:solidFill>
+                <a:latin typeface="DejaVu Sans"/>
+              </a:defRPr>
+            </a:pPr>
+            <a:r>
+              <a:t>APPENDIX • EVIDENCE</a:t>
+            </a:r>
+          </a:p>
+        </p:txBody>
+      </p:sp>
+      <p:sp>
+        <p:nvSpPr>
+          <p:cNvPr id="5" name="TextBox 4"/>
+          <p:cNvSpPr txBox="1"/>
+          <p:nvPr/>
+        </p:nvSpPr>
+        <p:spPr>
+          <a:xfrm>
+            <a:off x="502920" y="777240"/>
+            <a:ext cx="11247120" cy="731520"/>
+          </a:xfrm>
+          <a:prstGeom prst="rect">
+            <a:avLst/>
+          </a:prstGeom>
+          <a:noFill/>
+        </p:spPr>
+        <p:txBody>
+          <a:bodyPr wrap="none" lIns="0" rIns="0" tIns="0" bIns="0">
+            <a:spAutoFit/>
+          </a:bodyPr>
+          <a:lstStyle/>
+          <a:p>
+            <a:pPr>
+              <a:lnSpc>
+                <a:spcPts val="3600"/>
+              </a:lnSpc>
+              <a:spcAft>
+                <a:spcPts val="0"/>
+              </a:spcAft>
+              <a:defRPr sz="3000" b="1">
+                <a:solidFill>
+                  <a:srgbClr val="142E43"/>
+                </a:solidFill>
+                <a:latin typeface="DejaVu Sans"/>
+              </a:defRPr>
+            </a:pPr>
+            <a:r>
+              <a:t>Technical appendix: the saved runs differ</a:t>
+            </a:r>
+          </a:p>
+        </p:txBody>
+      </p:sp>
+      <p:sp>
+        <p:nvSpPr>
+          <p:cNvPr id="6" name="Rectangle 5"/>
+          <p:cNvSpPr/>
+          <p:nvPr/>
+        </p:nvSpPr>
+        <p:spPr>
+          <a:xfrm>
+            <a:off x="502920" y="6364224"/>
+            <a:ext cx="11155680" cy="13716"/>
+          </a:xfrm>
+          <a:prstGeom prst="rect">
+            <a:avLst/>
+          </a:prstGeom>
+          <a:solidFill>
+            <a:srgbClr val="D6E0E7"/>
+          </a:solidFill>
+          <a:ln>
+            <a:noFill/>
+          </a:ln>
+        </p:spPr>
+        <p:style>
+          <a:lnRef idx="1">
+            <a:schemeClr val="accent1"/>
+          </a:lnRef>
+          <a:fillRef idx="3">
+            <a:schemeClr val="accent1"/>
+          </a:fillRef>
+          <a:effectRef idx="2">
+            <a:schemeClr val="accent1"/>
+          </a:effectRef>
+          <a:fontRef idx="minor">
+            <a:schemeClr val="lt1"/>
+          </a:fontRef>
+        </p:style>
+        <p:txBody>
+          <a:bodyPr rtlCol="0" anchor="ctr"/>
+          <a:lstStyle/>
+          <a:p>
+            <a:pPr algn="ctr"/>
+          </a:p>
+        </p:txBody>
+      </p:sp>
+      <p:sp>
+        <p:nvSpPr>
+          <p:cNvPr id="7" name="TextBox 6"/>
+          <p:cNvSpPr txBox="1"/>
+          <p:nvPr/>
+        </p:nvSpPr>
+        <p:spPr>
+          <a:xfrm>
+            <a:off x="502920" y="6492240"/>
+            <a:ext cx="9144000" cy="201168"/>
+          </a:xfrm>
+          <a:prstGeom prst="rect">
+            <a:avLst/>
+          </a:prstGeom>
+          <a:noFill/>
+        </p:spPr>
+        <p:txBody>
+          <a:bodyPr wrap="none" lIns="0" rIns="0" tIns="0" bIns="0">
+            <a:spAutoFit/>
+          </a:bodyPr>
+          <a:lstStyle/>
+          <a:p>
+            <a:pPr>
+              <a:lnSpc>
+                <a:spcPts val="1200"/>
+              </a:lnSpc>
+              <a:spcAft>
+                <a:spcPts val="0"/>
+              </a:spcAft>
+              <a:defRPr sz="1000" b="0">
+                <a:solidFill>
+                  <a:srgbClr val="536777"/>
+                </a:solidFill>
+                <a:latin typeface="DejaVu Sans"/>
+              </a:defRPr>
+            </a:pPr>
+            <a:r>
+              <a:t>LAr optical map • From simulated events to detection probability</a:t>
+            </a:r>
+          </a:p>
+        </p:txBody>
+      </p:sp>
+      <p:sp>
+        <p:nvSpPr>
+          <p:cNvPr id="8" name="TextBox 7"/>
+          <p:cNvSpPr txBox="1"/>
+          <p:nvPr/>
+        </p:nvSpPr>
+        <p:spPr>
+          <a:xfrm>
+            <a:off x="11201400" y="6492240"/>
+            <a:ext cx="457200" cy="201168"/>
+          </a:xfrm>
+          <a:prstGeom prst="rect">
+            <a:avLst/>
+          </a:prstGeom>
+          <a:noFill/>
+        </p:spPr>
+        <p:txBody>
+          <a:bodyPr wrap="none" lIns="0" rIns="0" tIns="0" bIns="0">
+            <a:spAutoFit/>
+          </a:bodyPr>
+          <a:lstStyle/>
+          <a:p>
+            <a:pPr>
+              <a:lnSpc>
+                <a:spcPts val="1200"/>
+              </a:lnSpc>
+              <a:spcAft>
+                <a:spcPts val="0"/>
+              </a:spcAft>
+              <a:defRPr sz="1000" b="0">
+                <a:solidFill>
+                  <a:srgbClr val="536777"/>
+                </a:solidFill>
+                <a:latin typeface="DejaVu Sans"/>
+              </a:defRPr>
+            </a:pPr>
+            <a:r>
+              <a:t>16</a:t>
+            </a:r>
+          </a:p>
+        </p:txBody>
+      </p:sp>
+      <p:sp>
+        <p:nvSpPr>
+          <p:cNvPr id="9" name="Rectangle 8"/>
+          <p:cNvSpPr/>
+          <p:nvPr/>
+        </p:nvSpPr>
+        <p:spPr>
+          <a:xfrm>
+            <a:off x="502920" y="1691640"/>
+            <a:ext cx="2253996" cy="530352"/>
+          </a:xfrm>
+          <a:prstGeom prst="rect">
+            <a:avLst/>
+          </a:prstGeom>
+          <a:solidFill>
+            <a:srgbClr val="007F83"/>
+          </a:solidFill>
+          <a:ln>
+            <a:noFill/>
+          </a:ln>
+        </p:spPr>
+        <p:style>
+          <a:lnRef idx="1">
+            <a:schemeClr val="accent1"/>
+          </a:lnRef>
+          <a:fillRef idx="3">
+            <a:schemeClr val="accent1"/>
+          </a:fillRef>
+          <a:effectRef idx="2">
+            <a:schemeClr val="accent1"/>
+          </a:effectRef>
+          <a:fontRef idx="minor">
+            <a:schemeClr val="lt1"/>
+          </a:fontRef>
+        </p:style>
+        <p:txBody>
+          <a:bodyPr rtlCol="0" anchor="ctr"/>
+          <a:lstStyle/>
+          <a:p>
+            <a:pPr algn="ctr"/>
+          </a:p>
+        </p:txBody>
+      </p:sp>
+      <p:sp>
+        <p:nvSpPr>
+          <p:cNvPr id="10" name="TextBox 9"/>
+          <p:cNvSpPr txBox="1"/>
+          <p:nvPr/>
+        </p:nvSpPr>
+        <p:spPr>
+          <a:xfrm>
+            <a:off x="621792" y="1810512"/>
+            <a:ext cx="2057400" cy="365760"/>
+          </a:xfrm>
+          <a:prstGeom prst="rect">
+            <a:avLst/>
+          </a:prstGeom>
+          <a:noFill/>
+        </p:spPr>
+        <p:txBody>
+          <a:bodyPr wrap="none" lIns="0" rIns="0" tIns="0" bIns="0">
+            <a:spAutoFit/>
+          </a:bodyPr>
+          <a:lstStyle/>
+          <a:p>
+            <a:pPr>
+              <a:lnSpc>
+                <a:spcPts val="2039"/>
+              </a:lnSpc>
+              <a:spcAft>
+                <a:spcPts val="0"/>
+              </a:spcAft>
+              <a:defRPr sz="1700" b="1">
+                <a:solidFill>
+                  <a:srgbClr val="FFFFFF"/>
+                </a:solidFill>
+                <a:latin typeface="DejaVu Sans"/>
+              </a:defRPr>
+            </a:pPr>
+          </a:p>
+        </p:txBody>
+      </p:sp>
+      <p:sp>
+        <p:nvSpPr>
+          <p:cNvPr id="11" name="Rectangle 10"/>
+          <p:cNvSpPr/>
+          <p:nvPr/>
+        </p:nvSpPr>
+        <p:spPr>
+          <a:xfrm>
+            <a:off x="2788920" y="1691640"/>
+            <a:ext cx="4174235" cy="530352"/>
+          </a:xfrm>
+          <a:prstGeom prst="rect">
+            <a:avLst/>
+          </a:prstGeom>
+          <a:solidFill>
+            <a:srgbClr val="007F83"/>
+          </a:solidFill>
+          <a:ln>
+            <a:noFill/>
+          </a:ln>
+        </p:spPr>
+        <p:style>
+          <a:lnRef idx="1">
+            <a:schemeClr val="accent1"/>
+          </a:lnRef>
+          <a:fillRef idx="3">
+            <a:schemeClr val="accent1"/>
+          </a:fillRef>
+          <a:effectRef idx="2">
+            <a:schemeClr val="accent1"/>
+          </a:effectRef>
+          <a:fontRef idx="minor">
+            <a:schemeClr val="lt1"/>
+          </a:fontRef>
+        </p:style>
+        <p:txBody>
+          <a:bodyPr rtlCol="0" anchor="ctr"/>
+          <a:lstStyle/>
+          <a:p>
+            <a:pPr algn="ctr"/>
+          </a:p>
+        </p:txBody>
+      </p:sp>
+      <p:sp>
+        <p:nvSpPr>
+          <p:cNvPr id="12" name="TextBox 11"/>
+          <p:cNvSpPr txBox="1"/>
+          <p:nvPr/>
+        </p:nvSpPr>
+        <p:spPr>
+          <a:xfrm>
+            <a:off x="2907791" y="1810512"/>
+            <a:ext cx="3977639" cy="365760"/>
+          </a:xfrm>
+          <a:prstGeom prst="rect">
+            <a:avLst/>
+          </a:prstGeom>
+          <a:noFill/>
+        </p:spPr>
+        <p:txBody>
+          <a:bodyPr wrap="none" lIns="0" rIns="0" tIns="0" bIns="0">
+            <a:spAutoFit/>
+          </a:bodyPr>
+          <a:lstStyle/>
+          <a:p>
+            <a:pPr>
+              <a:lnSpc>
+                <a:spcPts val="2039"/>
+              </a:lnSpc>
+              <a:spcAft>
+                <a:spcPts val="0"/>
+              </a:spcAft>
+              <a:defRPr sz="1700" b="1">
+                <a:solidFill>
+                  <a:srgbClr val="FFFFFF"/>
+                </a:solidFill>
+                <a:latin typeface="DejaVu Sans"/>
+              </a:defRPr>
+            </a:pPr>
+            <a:r>
+              <a:t>Saved RESuM</a:t>
+            </a:r>
+          </a:p>
+        </p:txBody>
+      </p:sp>
+      <p:sp>
+        <p:nvSpPr>
+          <p:cNvPr id="13" name="Rectangle 12"/>
+          <p:cNvSpPr/>
+          <p:nvPr/>
+        </p:nvSpPr>
+        <p:spPr>
+          <a:xfrm>
+            <a:off x="6995159" y="1691640"/>
+            <a:ext cx="4631436" cy="530352"/>
+          </a:xfrm>
+          <a:prstGeom prst="rect">
+            <a:avLst/>
+          </a:prstGeom>
+          <a:solidFill>
+            <a:srgbClr val="007F83"/>
+          </a:solidFill>
+          <a:ln>
+            <a:noFill/>
+          </a:ln>
+        </p:spPr>
+        <p:style>
+          <a:lnRef idx="1">
+            <a:schemeClr val="accent1"/>
+          </a:lnRef>
+          <a:fillRef idx="3">
+            <a:schemeClr val="accent1"/>
+          </a:fillRef>
+          <a:effectRef idx="2">
+            <a:schemeClr val="accent1"/>
+          </a:effectRef>
+          <a:fontRef idx="minor">
+            <a:schemeClr val="lt1"/>
+          </a:fontRef>
+        </p:style>
+        <p:txBody>
+          <a:bodyPr rtlCol="0" anchor="ctr"/>
+          <a:lstStyle/>
+          <a:p>
+            <a:pPr algn="ctr"/>
+          </a:p>
+        </p:txBody>
+      </p:sp>
+      <p:sp>
+        <p:nvSpPr>
+          <p:cNvPr id="14" name="TextBox 13"/>
+          <p:cNvSpPr txBox="1"/>
+          <p:nvPr/>
+        </p:nvSpPr>
+        <p:spPr>
+          <a:xfrm>
+            <a:off x="7114031" y="1810512"/>
+            <a:ext cx="4434840" cy="365760"/>
+          </a:xfrm>
+          <a:prstGeom prst="rect">
+            <a:avLst/>
+          </a:prstGeom>
+          <a:noFill/>
+        </p:spPr>
+        <p:txBody>
+          <a:bodyPr wrap="none" lIns="0" rIns="0" tIns="0" bIns="0">
+            <a:spAutoFit/>
+          </a:bodyPr>
+          <a:lstStyle/>
+          <a:p>
+            <a:pPr>
+              <a:lnSpc>
+                <a:spcPts val="2039"/>
+              </a:lnSpc>
+              <a:spcAft>
+                <a:spcPts val="0"/>
+              </a:spcAft>
+              <a:defRPr sz="1700" b="1">
+                <a:solidFill>
+                  <a:srgbClr val="FFFFFF"/>
+                </a:solidFill>
+                <a:latin typeface="DejaVu Sans"/>
+              </a:defRPr>
+            </a:pPr>
+            <a:r>
+              <a:t>Saved binomial GP</a:t>
+            </a:r>
+          </a:p>
+        </p:txBody>
+      </p:sp>
+      <p:sp>
+        <p:nvSpPr>
+          <p:cNvPr id="15" name="Rectangle 14"/>
+          <p:cNvSpPr/>
+          <p:nvPr/>
+        </p:nvSpPr>
+        <p:spPr>
+          <a:xfrm>
+            <a:off x="502920" y="2258568"/>
+            <a:ext cx="2253996" cy="690372"/>
+          </a:xfrm>
+          <a:prstGeom prst="rect">
+            <a:avLst/>
+          </a:prstGeom>
+          <a:solidFill>
+            <a:srgbClr val="FFFFFF"/>
+          </a:solidFill>
+          <a:ln>
+            <a:noFill/>
+          </a:ln>
+        </p:spPr>
+        <p:style>
+          <a:lnRef idx="1">
+            <a:schemeClr val="accent1"/>
+          </a:lnRef>
+          <a:fillRef idx="3">
+            <a:schemeClr val="accent1"/>
+          </a:fillRef>
+          <a:effectRef idx="2">
+            <a:schemeClr val="accent1"/>
+          </a:effectRef>
+          <a:fontRef idx="minor">
+            <a:schemeClr val="lt1"/>
+          </a:fontRef>
+        </p:style>
+        <p:txBody>
+          <a:bodyPr rtlCol="0" anchor="ctr"/>
+          <a:lstStyle/>
+          <a:p>
+            <a:pPr algn="ctr"/>
+          </a:p>
+        </p:txBody>
+      </p:sp>
+      <p:sp>
+        <p:nvSpPr>
+          <p:cNvPr id="16" name="TextBox 15"/>
+          <p:cNvSpPr txBox="1"/>
+          <p:nvPr/>
+        </p:nvSpPr>
+        <p:spPr>
+          <a:xfrm>
+            <a:off x="621792" y="2368296"/>
+            <a:ext cx="2057400" cy="603504"/>
+          </a:xfrm>
+          <a:prstGeom prst="rect">
+            <a:avLst/>
+          </a:prstGeom>
+          <a:noFill/>
+        </p:spPr>
+        <p:txBody>
+          <a:bodyPr wrap="none" lIns="0" rIns="0" tIns="0" bIns="0">
+            <a:spAutoFit/>
+          </a:bodyPr>
+          <a:lstStyle/>
+          <a:p>
+            <a:pPr>
+              <a:lnSpc>
+                <a:spcPts val="1920"/>
+              </a:lnSpc>
+              <a:spcAft>
+                <a:spcPts val="0"/>
+              </a:spcAft>
+              <a:defRPr sz="1600" b="0">
+                <a:solidFill>
+                  <a:srgbClr val="142E43"/>
+                </a:solidFill>
+                <a:latin typeface="DejaVu Sans"/>
+              </a:defRPr>
+            </a:pPr>
+            <a:r>
+              <a:t>LF training</a:t>
+            </a:r>
+          </a:p>
+        </p:txBody>
+      </p:sp>
+      <p:sp>
+        <p:nvSpPr>
+          <p:cNvPr id="17" name="Rectangle 16"/>
+          <p:cNvSpPr/>
+          <p:nvPr/>
+        </p:nvSpPr>
+        <p:spPr>
+          <a:xfrm>
+            <a:off x="2788920" y="2258568"/>
+            <a:ext cx="4174235" cy="690372"/>
+          </a:xfrm>
+          <a:prstGeom prst="rect">
+            <a:avLst/>
+          </a:prstGeom>
+          <a:solidFill>
+            <a:srgbClr val="FFFFFF"/>
+          </a:solidFill>
+          <a:ln>
+            <a:noFill/>
+          </a:ln>
+        </p:spPr>
+        <p:style>
+          <a:lnRef idx="1">
+            <a:schemeClr val="accent1"/>
+          </a:lnRef>
+          <a:fillRef idx="3">
+            <a:schemeClr val="accent1"/>
+          </a:fillRef>
+          <a:effectRef idx="2">
+            <a:schemeClr val="accent1"/>
+          </a:effectRef>
+          <a:fontRef idx="minor">
+            <a:schemeClr val="lt1"/>
+          </a:fontRef>
+        </p:style>
+        <p:txBody>
+          <a:bodyPr rtlCol="0" anchor="ctr"/>
+          <a:lstStyle/>
+          <a:p>
+            <a:pPr algn="ctr"/>
+          </a:p>
+        </p:txBody>
+      </p:sp>
+      <p:sp>
+        <p:nvSpPr>
+          <p:cNvPr id="18" name="TextBox 17"/>
+          <p:cNvSpPr txBox="1"/>
+          <p:nvPr/>
+        </p:nvSpPr>
+        <p:spPr>
+          <a:xfrm>
+            <a:off x="2907791" y="2368296"/>
+            <a:ext cx="3977639" cy="603504"/>
+          </a:xfrm>
+          <a:prstGeom prst="rect">
+            <a:avLst/>
+          </a:prstGeom>
+          <a:noFill/>
+        </p:spPr>
+        <p:txBody>
+          <a:bodyPr wrap="none" lIns="0" rIns="0" tIns="0" bIns="0">
+            <a:spAutoFit/>
+          </a:bodyPr>
+          <a:lstStyle/>
+          <a:p>
+            <a:pPr>
+              <a:lnSpc>
+                <a:spcPts val="1920"/>
+              </a:lnSpc>
+              <a:spcAft>
+                <a:spcPts val="0"/>
+              </a:spcAft>
+              <a:defRPr sz="1600" b="0">
+                <a:solidFill>
+                  <a:srgbClr val="142E43"/>
+                </a:solidFill>
+                <a:latin typeface="DejaVu Sans"/>
+              </a:defRPr>
+            </a:pPr>
+            <a:r>
+              <a:t>159 nonzero N1500 voxels</a:t>
+            </a:r>
+          </a:p>
+        </p:txBody>
+      </p:sp>
+      <p:sp>
+        <p:nvSpPr>
+          <p:cNvPr id="19" name="Rectangle 18"/>
+          <p:cNvSpPr/>
+          <p:nvPr/>
+        </p:nvSpPr>
+        <p:spPr>
+          <a:xfrm>
+            <a:off x="6995159" y="2258568"/>
+            <a:ext cx="4631436" cy="690372"/>
+          </a:xfrm>
+          <a:prstGeom prst="rect">
+            <a:avLst/>
+          </a:prstGeom>
+          <a:solidFill>
+            <a:srgbClr val="FFFFFF"/>
+          </a:solidFill>
+          <a:ln>
+            <a:noFill/>
+          </a:ln>
+        </p:spPr>
+        <p:style>
+          <a:lnRef idx="1">
+            <a:schemeClr val="accent1"/>
+          </a:lnRef>
+          <a:fillRef idx="3">
+            <a:schemeClr val="accent1"/>
+          </a:fillRef>
+          <a:effectRef idx="2">
+            <a:schemeClr val="accent1"/>
+          </a:effectRef>
+          <a:fontRef idx="minor">
+            <a:schemeClr val="lt1"/>
+          </a:fontRef>
+        </p:style>
+        <p:txBody>
+          <a:bodyPr rtlCol="0" anchor="ctr"/>
+          <a:lstStyle/>
+          <a:p>
+            <a:pPr algn="ctr"/>
+          </a:p>
+        </p:txBody>
+      </p:sp>
+      <p:sp>
+        <p:nvSpPr>
+          <p:cNvPr id="20" name="TextBox 19"/>
+          <p:cNvSpPr txBox="1"/>
+          <p:nvPr/>
+        </p:nvSpPr>
+        <p:spPr>
+          <a:xfrm>
+            <a:off x="7114031" y="2368296"/>
+            <a:ext cx="4434840" cy="603504"/>
+          </a:xfrm>
+          <a:prstGeom prst="rect">
+            <a:avLst/>
+          </a:prstGeom>
+          <a:noFill/>
+        </p:spPr>
+        <p:txBody>
+          <a:bodyPr wrap="none" lIns="0" rIns="0" tIns="0" bIns="0">
+            <a:spAutoFit/>
+          </a:bodyPr>
+          <a:lstStyle/>
+          <a:p>
+            <a:pPr>
+              <a:lnSpc>
+                <a:spcPts val="1920"/>
+              </a:lnSpc>
+              <a:spcAft>
+                <a:spcPts val="0"/>
+              </a:spcAft>
+              <a:defRPr sz="1600" b="0">
+                <a:solidFill>
+                  <a:srgbClr val="142E43"/>
+                </a:solidFill>
+                <a:latin typeface="DejaVu Sans"/>
+              </a:defRPr>
+            </a:pPr>
+            <a:r>
+              <a:t>760 across N500–N1500; includes zeros</a:t>
+            </a:r>
+          </a:p>
+        </p:txBody>
+      </p:sp>
+      <p:sp>
+        <p:nvSpPr>
+          <p:cNvPr id="21" name="Rectangle 20"/>
+          <p:cNvSpPr/>
+          <p:nvPr/>
+        </p:nvSpPr>
+        <p:spPr>
+          <a:xfrm>
+            <a:off x="502920" y="2971800"/>
+            <a:ext cx="2253996" cy="690372"/>
+          </a:xfrm>
+          <a:prstGeom prst="rect">
+            <a:avLst/>
+          </a:prstGeom>
+          <a:solidFill>
+            <a:srgbClr val="E8EFF3"/>
+          </a:solidFill>
+          <a:ln>
+            <a:noFill/>
+          </a:ln>
+        </p:spPr>
+        <p:style>
+          <a:lnRef idx="1">
+            <a:schemeClr val="accent1"/>
+          </a:lnRef>
+          <a:fillRef idx="3">
+            <a:schemeClr val="accent1"/>
+          </a:fillRef>
+          <a:effectRef idx="2">
+            <a:schemeClr val="accent1"/>
+          </a:effectRef>
+          <a:fontRef idx="minor">
+            <a:schemeClr val="lt1"/>
+          </a:fontRef>
+        </p:style>
+        <p:txBody>
+          <a:bodyPr rtlCol="0" anchor="ctr"/>
+          <a:lstStyle/>
+          <a:p>
+            <a:pPr algn="ctr"/>
+          </a:p>
+        </p:txBody>
+      </p:sp>
+      <p:sp>
+        <p:nvSpPr>
+          <p:cNvPr id="22" name="TextBox 21"/>
+          <p:cNvSpPr txBox="1"/>
+          <p:nvPr/>
+        </p:nvSpPr>
+        <p:spPr>
+          <a:xfrm>
+            <a:off x="621792" y="3081528"/>
+            <a:ext cx="2057400" cy="603504"/>
+          </a:xfrm>
+          <a:prstGeom prst="rect">
+            <a:avLst/>
+          </a:prstGeom>
+          <a:noFill/>
+        </p:spPr>
+        <p:txBody>
+          <a:bodyPr wrap="none" lIns="0" rIns="0" tIns="0" bIns="0">
+            <a:spAutoFit/>
+          </a:bodyPr>
+          <a:lstStyle/>
+          <a:p>
+            <a:pPr>
+              <a:lnSpc>
+                <a:spcPts val="1920"/>
+              </a:lnSpc>
+              <a:spcAft>
+                <a:spcPts val="0"/>
+              </a:spcAft>
+              <a:defRPr sz="1600" b="0">
+                <a:solidFill>
+                  <a:srgbClr val="142E43"/>
+                </a:solidFill>
+                <a:latin typeface="DejaVu Sans"/>
+              </a:defRPr>
+            </a:pPr>
+            <a:r>
+              <a:t>HF training</a:t>
+            </a:r>
+          </a:p>
+        </p:txBody>
+      </p:sp>
+      <p:sp>
+        <p:nvSpPr>
+          <p:cNvPr id="23" name="Rectangle 22"/>
+          <p:cNvSpPr/>
+          <p:nvPr/>
+        </p:nvSpPr>
+        <p:spPr>
+          <a:xfrm>
+            <a:off x="2788920" y="2971800"/>
+            <a:ext cx="4174235" cy="690372"/>
+          </a:xfrm>
+          <a:prstGeom prst="rect">
+            <a:avLst/>
+          </a:prstGeom>
+          <a:solidFill>
+            <a:srgbClr val="E8EFF3"/>
+          </a:solidFill>
+          <a:ln>
+            <a:noFill/>
+          </a:ln>
+        </p:spPr>
+        <p:style>
+          <a:lnRef idx="1">
+            <a:schemeClr val="accent1"/>
+          </a:lnRef>
+          <a:fillRef idx="3">
+            <a:schemeClr val="accent1"/>
+          </a:fillRef>
+          <a:effectRef idx="2">
+            <a:schemeClr val="accent1"/>
+          </a:effectRef>
+          <a:fontRef idx="minor">
+            <a:schemeClr val="lt1"/>
+          </a:fontRef>
+        </p:style>
+        <p:txBody>
+          <a:bodyPr rtlCol="0" anchor="ctr"/>
+          <a:lstStyle/>
+          <a:p>
+            <a:pPr algn="ctr"/>
+          </a:p>
+        </p:txBody>
+      </p:sp>
+      <p:sp>
+        <p:nvSpPr>
+          <p:cNvPr id="24" name="TextBox 23"/>
+          <p:cNvSpPr txBox="1"/>
+          <p:nvPr/>
+        </p:nvSpPr>
+        <p:spPr>
+          <a:xfrm>
+            <a:off x="2907791" y="3081528"/>
+            <a:ext cx="3977639" cy="603504"/>
+          </a:xfrm>
+          <a:prstGeom prst="rect">
+            <a:avLst/>
+          </a:prstGeom>
+          <a:noFill/>
+        </p:spPr>
+        <p:txBody>
+          <a:bodyPr wrap="none" lIns="0" rIns="0" tIns="0" bIns="0">
+            <a:spAutoFit/>
+          </a:bodyPr>
+          <a:lstStyle/>
+          <a:p>
+            <a:pPr>
+              <a:lnSpc>
+                <a:spcPts val="1920"/>
+              </a:lnSpc>
+              <a:spcAft>
+                <a:spcPts val="0"/>
+              </a:spcAft>
+              <a:defRPr sz="1600" b="0">
+                <a:solidFill>
+                  <a:srgbClr val="142E43"/>
+                </a:solidFill>
+                <a:latin typeface="DejaVu Sans"/>
+              </a:defRPr>
+            </a:pPr>
+            <a:r>
+              <a:t>10 nonzero voxels</a:t>
+            </a:r>
+          </a:p>
+        </p:txBody>
+      </p:sp>
+      <p:sp>
+        <p:nvSpPr>
+          <p:cNvPr id="25" name="Rectangle 24"/>
+          <p:cNvSpPr/>
+          <p:nvPr/>
+        </p:nvSpPr>
+        <p:spPr>
+          <a:xfrm>
+            <a:off x="6995159" y="2971800"/>
+            <a:ext cx="4631436" cy="690372"/>
+          </a:xfrm>
+          <a:prstGeom prst="rect">
+            <a:avLst/>
+          </a:prstGeom>
+          <a:solidFill>
+            <a:srgbClr val="E8EFF3"/>
+          </a:solidFill>
+          <a:ln>
+            <a:noFill/>
+          </a:ln>
+        </p:spPr>
+        <p:style>
+          <a:lnRef idx="1">
+            <a:schemeClr val="accent1"/>
+          </a:lnRef>
+          <a:fillRef idx="3">
+            <a:schemeClr val="accent1"/>
+          </a:fillRef>
+          <a:effectRef idx="2">
+            <a:schemeClr val="accent1"/>
+          </a:effectRef>
+          <a:fontRef idx="minor">
+            <a:schemeClr val="lt1"/>
+          </a:fontRef>
+        </p:style>
+        <p:txBody>
+          <a:bodyPr rtlCol="0" anchor="ctr"/>
+          <a:lstStyle/>
+          <a:p>
+            <a:pPr algn="ctr"/>
+          </a:p>
+        </p:txBody>
+      </p:sp>
+      <p:sp>
+        <p:nvSpPr>
+          <p:cNvPr id="26" name="TextBox 25"/>
+          <p:cNvSpPr txBox="1"/>
+          <p:nvPr/>
+        </p:nvSpPr>
+        <p:spPr>
+          <a:xfrm>
+            <a:off x="7114031" y="3081528"/>
+            <a:ext cx="4434840" cy="603504"/>
+          </a:xfrm>
+          <a:prstGeom prst="rect">
+            <a:avLst/>
+          </a:prstGeom>
+          <a:noFill/>
+        </p:spPr>
+        <p:txBody>
+          <a:bodyPr wrap="none" lIns="0" rIns="0" tIns="0" bIns="0">
+            <a:spAutoFit/>
+          </a:bodyPr>
+          <a:lstStyle/>
+          <a:p>
+            <a:pPr>
+              <a:lnSpc>
+                <a:spcPts val="1920"/>
+              </a:lnSpc>
+              <a:spcAft>
+                <a:spcPts val="0"/>
+              </a:spcAft>
+              <a:defRPr sz="1600" b="0">
+                <a:solidFill>
+                  <a:srgbClr val="142E43"/>
+                </a:solidFill>
+                <a:latin typeface="DejaVu Sans"/>
+              </a:defRPr>
+            </a:pPr>
+            <a:r>
+              <a:t>10 voxels, including 1 zero-hit</a:t>
+            </a:r>
+          </a:p>
+        </p:txBody>
+      </p:sp>
+      <p:sp>
+        <p:nvSpPr>
+          <p:cNvPr id="27" name="Rectangle 26"/>
+          <p:cNvSpPr/>
+          <p:nvPr/>
+        </p:nvSpPr>
+        <p:spPr>
+          <a:xfrm>
+            <a:off x="502920" y="3685032"/>
+            <a:ext cx="2253996" cy="690372"/>
+          </a:xfrm>
+          <a:prstGeom prst="rect">
+            <a:avLst/>
+          </a:prstGeom>
+          <a:solidFill>
+            <a:srgbClr val="FFFFFF"/>
+          </a:solidFill>
+          <a:ln>
+            <a:noFill/>
+          </a:ln>
+        </p:spPr>
+        <p:style>
+          <a:lnRef idx="1">
+            <a:schemeClr val="accent1"/>
+          </a:lnRef>
+          <a:fillRef idx="3">
+            <a:schemeClr val="accent1"/>
+          </a:fillRef>
+          <a:effectRef idx="2">
+            <a:schemeClr val="accent1"/>
+          </a:effectRef>
+          <a:fontRef idx="minor">
+            <a:schemeClr val="lt1"/>
+          </a:fontRef>
+        </p:style>
+        <p:txBody>
+          <a:bodyPr rtlCol="0" anchor="ctr"/>
+          <a:lstStyle/>
+          <a:p>
+            <a:pPr algn="ctr"/>
+          </a:p>
+        </p:txBody>
+      </p:sp>
+      <p:sp>
+        <p:nvSpPr>
+          <p:cNvPr id="28" name="TextBox 27"/>
+          <p:cNvSpPr txBox="1"/>
+          <p:nvPr/>
+        </p:nvSpPr>
+        <p:spPr>
+          <a:xfrm>
+            <a:off x="621792" y="3794760"/>
+            <a:ext cx="2057400" cy="603504"/>
+          </a:xfrm>
+          <a:prstGeom prst="rect">
+            <a:avLst/>
+          </a:prstGeom>
+          <a:noFill/>
+        </p:spPr>
+        <p:txBody>
+          <a:bodyPr wrap="none" lIns="0" rIns="0" tIns="0" bIns="0">
+            <a:spAutoFit/>
+          </a:bodyPr>
+          <a:lstStyle/>
+          <a:p>
+            <a:pPr>
+              <a:lnSpc>
+                <a:spcPts val="1920"/>
+              </a:lnSpc>
+              <a:spcAft>
+                <a:spcPts val="0"/>
+              </a:spcAft>
+              <a:defRPr sz="1600" b="0">
+                <a:solidFill>
+                  <a:srgbClr val="142E43"/>
+                </a:solidFill>
+                <a:latin typeface="DejaVu Sans"/>
+              </a:defRPr>
+            </a:pPr>
+            <a:r>
+              <a:t>HF validation</a:t>
+            </a:r>
+          </a:p>
+        </p:txBody>
+      </p:sp>
+      <p:sp>
+        <p:nvSpPr>
+          <p:cNvPr id="29" name="Rectangle 28"/>
+          <p:cNvSpPr/>
+          <p:nvPr/>
+        </p:nvSpPr>
+        <p:spPr>
+          <a:xfrm>
+            <a:off x="2788920" y="3685032"/>
+            <a:ext cx="4174235" cy="690372"/>
+          </a:xfrm>
+          <a:prstGeom prst="rect">
+            <a:avLst/>
+          </a:prstGeom>
+          <a:solidFill>
+            <a:srgbClr val="FFFFFF"/>
+          </a:solidFill>
+          <a:ln>
+            <a:noFill/>
+          </a:ln>
+        </p:spPr>
+        <p:style>
+          <a:lnRef idx="1">
+            <a:schemeClr val="accent1"/>
+          </a:lnRef>
+          <a:fillRef idx="3">
+            <a:schemeClr val="accent1"/>
+          </a:fillRef>
+          <a:effectRef idx="2">
+            <a:schemeClr val="accent1"/>
+          </a:effectRef>
+          <a:fontRef idx="minor">
+            <a:schemeClr val="lt1"/>
+          </a:fontRef>
+        </p:style>
+        <p:txBody>
+          <a:bodyPr rtlCol="0" anchor="ctr"/>
+          <a:lstStyle/>
+          <a:p>
+            <a:pPr algn="ctr"/>
+          </a:p>
+        </p:txBody>
+      </p:sp>
+      <p:sp>
+        <p:nvSpPr>
+          <p:cNvPr id="30" name="TextBox 29"/>
+          <p:cNvSpPr txBox="1"/>
+          <p:nvPr/>
+        </p:nvSpPr>
+        <p:spPr>
+          <a:xfrm>
+            <a:off x="2907791" y="3794760"/>
+            <a:ext cx="3977639" cy="603504"/>
+          </a:xfrm>
+          <a:prstGeom prst="rect">
+            <a:avLst/>
+          </a:prstGeom>
+          <a:noFill/>
+        </p:spPr>
+        <p:txBody>
+          <a:bodyPr wrap="none" lIns="0" rIns="0" tIns="0" bIns="0">
+            <a:spAutoFit/>
+          </a:bodyPr>
+          <a:lstStyle/>
+          <a:p>
+            <a:pPr>
+              <a:lnSpc>
+                <a:spcPts val="1920"/>
+              </a:lnSpc>
+              <a:spcAft>
+                <a:spcPts val="0"/>
+              </a:spcAft>
+              <a:defRPr sz="1600" b="0">
+                <a:solidFill>
+                  <a:srgbClr val="142E43"/>
+                </a:solidFill>
+                <a:latin typeface="DejaVu Sans"/>
+              </a:defRPr>
+            </a:pPr>
+            <a:r>
+              <a:t>46 nonzero voxels</a:t>
+            </a:r>
+          </a:p>
+        </p:txBody>
+      </p:sp>
+      <p:sp>
+        <p:nvSpPr>
+          <p:cNvPr id="31" name="Rectangle 30"/>
+          <p:cNvSpPr/>
+          <p:nvPr/>
+        </p:nvSpPr>
+        <p:spPr>
+          <a:xfrm>
+            <a:off x="6995159" y="3685032"/>
+            <a:ext cx="4631436" cy="690372"/>
+          </a:xfrm>
+          <a:prstGeom prst="rect">
+            <a:avLst/>
+          </a:prstGeom>
+          <a:solidFill>
+            <a:srgbClr val="FFFFFF"/>
+          </a:solidFill>
+          <a:ln>
+            <a:noFill/>
+          </a:ln>
+        </p:spPr>
+        <p:style>
+          <a:lnRef idx="1">
+            <a:schemeClr val="accent1"/>
+          </a:lnRef>
+          <a:fillRef idx="3">
+            <a:schemeClr val="accent1"/>
+          </a:fillRef>
+          <a:effectRef idx="2">
+            <a:schemeClr val="accent1"/>
+          </a:effectRef>
+          <a:fontRef idx="minor">
+            <a:schemeClr val="lt1"/>
+          </a:fontRef>
+        </p:style>
+        <p:txBody>
+          <a:bodyPr rtlCol="0" anchor="ctr"/>
+          <a:lstStyle/>
+          <a:p>
+            <a:pPr algn="ctr"/>
+          </a:p>
+        </p:txBody>
+      </p:sp>
+      <p:sp>
+        <p:nvSpPr>
+          <p:cNvPr id="32" name="TextBox 31"/>
+          <p:cNvSpPr txBox="1"/>
+          <p:nvPr/>
+        </p:nvSpPr>
+        <p:spPr>
+          <a:xfrm>
+            <a:off x="7114031" y="3794760"/>
+            <a:ext cx="4434840" cy="603504"/>
+          </a:xfrm>
+          <a:prstGeom prst="rect">
+            <a:avLst/>
+          </a:prstGeom>
+          <a:noFill/>
+        </p:spPr>
+        <p:txBody>
+          <a:bodyPr wrap="none" lIns="0" rIns="0" tIns="0" bIns="0">
+            <a:spAutoFit/>
+          </a:bodyPr>
+          <a:lstStyle/>
+          <a:p>
+            <a:pPr>
+              <a:lnSpc>
+                <a:spcPts val="1920"/>
+              </a:lnSpc>
+              <a:spcAft>
+                <a:spcPts val="0"/>
+              </a:spcAft>
+              <a:defRPr sz="1600" b="0">
+                <a:solidFill>
+                  <a:srgbClr val="142E43"/>
+                </a:solidFill>
+                <a:latin typeface="DejaVu Sans"/>
+              </a:defRPr>
+            </a:pPr>
+            <a:r>
+              <a:t>55 voxels, including 8 zero-hit</a:t>
+            </a:r>
+          </a:p>
+        </p:txBody>
+      </p:sp>
+      <p:sp>
+        <p:nvSpPr>
+          <p:cNvPr id="33" name="Rectangle 32"/>
+          <p:cNvSpPr/>
+          <p:nvPr/>
+        </p:nvSpPr>
+        <p:spPr>
+          <a:xfrm>
+            <a:off x="502920" y="4398264"/>
+            <a:ext cx="2253996" cy="690372"/>
+          </a:xfrm>
+          <a:prstGeom prst="rect">
+            <a:avLst/>
+          </a:prstGeom>
+          <a:solidFill>
+            <a:srgbClr val="E8EFF3"/>
+          </a:solidFill>
+          <a:ln>
+            <a:noFill/>
+          </a:ln>
+        </p:spPr>
+        <p:style>
+          <a:lnRef idx="1">
+            <a:schemeClr val="accent1"/>
+          </a:lnRef>
+          <a:fillRef idx="3">
+            <a:schemeClr val="accent1"/>
+          </a:fillRef>
+          <a:effectRef idx="2">
+            <a:schemeClr val="accent1"/>
+          </a:effectRef>
+          <a:fontRef idx="minor">
+            <a:schemeClr val="lt1"/>
+          </a:fontRef>
+        </p:style>
+        <p:txBody>
+          <a:bodyPr rtlCol="0" anchor="ctr"/>
+          <a:lstStyle/>
+          <a:p>
+            <a:pPr algn="ctr"/>
+          </a:p>
+        </p:txBody>
+      </p:sp>
+      <p:sp>
+        <p:nvSpPr>
+          <p:cNvPr id="34" name="TextBox 33"/>
+          <p:cNvSpPr txBox="1"/>
+          <p:nvPr/>
+        </p:nvSpPr>
+        <p:spPr>
+          <a:xfrm>
+            <a:off x="621792" y="4507992"/>
+            <a:ext cx="2057400" cy="603504"/>
+          </a:xfrm>
+          <a:prstGeom prst="rect">
+            <a:avLst/>
+          </a:prstGeom>
+          <a:noFill/>
+        </p:spPr>
+        <p:txBody>
+          <a:bodyPr wrap="none" lIns="0" rIns="0" tIns="0" bIns="0">
+            <a:spAutoFit/>
+          </a:bodyPr>
+          <a:lstStyle/>
+          <a:p>
+            <a:pPr>
+              <a:lnSpc>
+                <a:spcPts val="1920"/>
+              </a:lnSpc>
+              <a:spcAft>
+                <a:spcPts val="0"/>
+              </a:spcAft>
+              <a:defRPr sz="1600" b="0">
+                <a:solidFill>
+                  <a:srgbClr val="142E43"/>
+                </a:solidFill>
+                <a:latin typeface="DejaVu Sans"/>
+              </a:defRPr>
+            </a:pPr>
+            <a:r>
+              <a:t>HF primary budget</a:t>
+            </a:r>
+          </a:p>
+        </p:txBody>
+      </p:sp>
+      <p:sp>
+        <p:nvSpPr>
+          <p:cNvPr id="35" name="Rectangle 34"/>
+          <p:cNvSpPr/>
+          <p:nvPr/>
+        </p:nvSpPr>
+        <p:spPr>
+          <a:xfrm>
+            <a:off x="2788920" y="4398264"/>
+            <a:ext cx="4174235" cy="690372"/>
+          </a:xfrm>
+          <a:prstGeom prst="rect">
+            <a:avLst/>
+          </a:prstGeom>
+          <a:solidFill>
+            <a:srgbClr val="E8EFF3"/>
+          </a:solidFill>
+          <a:ln>
+            <a:noFill/>
+          </a:ln>
+        </p:spPr>
+        <p:style>
+          <a:lnRef idx="1">
+            <a:schemeClr val="accent1"/>
+          </a:lnRef>
+          <a:fillRef idx="3">
+            <a:schemeClr val="accent1"/>
+          </a:fillRef>
+          <a:effectRef idx="2">
+            <a:schemeClr val="accent1"/>
+          </a:effectRef>
+          <a:fontRef idx="minor">
+            <a:schemeClr val="lt1"/>
+          </a:fontRef>
+        </p:style>
+        <p:txBody>
+          <a:bodyPr rtlCol="0" anchor="ctr"/>
+          <a:lstStyle/>
+          <a:p>
+            <a:pPr algn="ctr"/>
+          </a:p>
+        </p:txBody>
+      </p:sp>
+      <p:sp>
+        <p:nvSpPr>
+          <p:cNvPr id="36" name="TextBox 35"/>
+          <p:cNvSpPr txBox="1"/>
+          <p:nvPr/>
+        </p:nvSpPr>
+        <p:spPr>
+          <a:xfrm>
+            <a:off x="2907791" y="4507992"/>
+            <a:ext cx="3977639" cy="603504"/>
+          </a:xfrm>
+          <a:prstGeom prst="rect">
+            <a:avLst/>
+          </a:prstGeom>
+          <a:noFill/>
+        </p:spPr>
+        <p:txBody>
+          <a:bodyPr wrap="none" lIns="0" rIns="0" tIns="0" bIns="0">
+            <a:spAutoFit/>
+          </a:bodyPr>
+          <a:lstStyle/>
+          <a:p>
+            <a:pPr>
+              <a:lnSpc>
+                <a:spcPts val="1920"/>
+              </a:lnSpc>
+              <a:spcAft>
+                <a:spcPts val="0"/>
+              </a:spcAft>
+              <a:defRPr sz="1600" b="0">
+                <a:solidFill>
+                  <a:srgbClr val="142E43"/>
+                </a:solidFill>
+                <a:latin typeface="DejaVu Sans"/>
+              </a:defRPr>
+            </a:pPr>
+            <a:r>
+              <a:t>4936 after context removal</a:t>
+            </a:r>
+          </a:p>
+        </p:txBody>
+      </p:sp>
+      <p:sp>
+        <p:nvSpPr>
+          <p:cNvPr id="37" name="Rectangle 36"/>
+          <p:cNvSpPr/>
+          <p:nvPr/>
+        </p:nvSpPr>
+        <p:spPr>
+          <a:xfrm>
+            <a:off x="6995159" y="4398264"/>
+            <a:ext cx="4631436" cy="690372"/>
+          </a:xfrm>
+          <a:prstGeom prst="rect">
+            <a:avLst/>
+          </a:prstGeom>
+          <a:solidFill>
+            <a:srgbClr val="E8EFF3"/>
+          </a:solidFill>
+          <a:ln>
+            <a:noFill/>
+          </a:ln>
+        </p:spPr>
+        <p:style>
+          <a:lnRef idx="1">
+            <a:schemeClr val="accent1"/>
+          </a:lnRef>
+          <a:fillRef idx="3">
+            <a:schemeClr val="accent1"/>
+          </a:fillRef>
+          <a:effectRef idx="2">
+            <a:schemeClr val="accent1"/>
+          </a:effectRef>
+          <a:fontRef idx="minor">
+            <a:schemeClr val="lt1"/>
+          </a:fontRef>
+        </p:style>
+        <p:txBody>
+          <a:bodyPr rtlCol="0" anchor="ctr"/>
+          <a:lstStyle/>
+          <a:p>
+            <a:pPr algn="ctr"/>
+          </a:p>
+        </p:txBody>
+      </p:sp>
+      <p:sp>
+        <p:nvSpPr>
+          <p:cNvPr id="38" name="TextBox 37"/>
+          <p:cNvSpPr txBox="1"/>
+          <p:nvPr/>
+        </p:nvSpPr>
+        <p:spPr>
+          <a:xfrm>
+            <a:off x="7114031" y="4507992"/>
+            <a:ext cx="4434840" cy="603504"/>
+          </a:xfrm>
+          <a:prstGeom prst="rect">
+            <a:avLst/>
+          </a:prstGeom>
+          <a:noFill/>
+        </p:spPr>
+        <p:txBody>
+          <a:bodyPr wrap="none" lIns="0" rIns="0" tIns="0" bIns="0">
+            <a:spAutoFit/>
+          </a:bodyPr>
+          <a:lstStyle/>
+          <a:p>
+            <a:pPr>
+              <a:lnSpc>
+                <a:spcPts val="1920"/>
+              </a:lnSpc>
+              <a:spcAft>
+                <a:spcPts val="0"/>
+              </a:spcAft>
+              <a:defRPr sz="1600" b="0">
+                <a:solidFill>
+                  <a:srgbClr val="142E43"/>
+                </a:solidFill>
+                <a:latin typeface="DejaVu Sans"/>
+              </a:defRPr>
+            </a:pPr>
+            <a:r>
+              <a:t>Full 5000</a:t>
+            </a:r>
+          </a:p>
+        </p:txBody>
+      </p:sp>
+      <p:sp>
+        <p:nvSpPr>
+          <p:cNvPr id="39" name="TextBox 38"/>
+          <p:cNvSpPr txBox="1"/>
+          <p:nvPr/>
+        </p:nvSpPr>
+        <p:spPr>
+          <a:xfrm>
+            <a:off x="594360" y="5852160"/>
+            <a:ext cx="10972800" cy="411480"/>
+          </a:xfrm>
+          <a:prstGeom prst="rect">
+            <a:avLst/>
+          </a:prstGeom>
+          <a:noFill/>
+        </p:spPr>
+        <p:txBody>
+          <a:bodyPr wrap="none" lIns="0" rIns="0" tIns="0" bIns="0">
+            <a:spAutoFit/>
+          </a:bodyPr>
+          <a:lstStyle/>
+          <a:p>
+            <a:pPr>
+              <a:lnSpc>
+                <a:spcPts val="1800"/>
+              </a:lnSpc>
+              <a:spcAft>
+                <a:spcPts val="0"/>
+              </a:spcAft>
+              <a:defRPr sz="1500" b="0">
+                <a:solidFill>
+                  <a:srgbClr val="536777"/>
+                </a:solidFill>
+                <a:latin typeface="DejaVu Sans"/>
+              </a:defRPr>
+            </a:pPr>
+            <a:r>
+              <a:t>Different data and targets can change results independently of the modeling approach.</a:t>
+            </a:r>
+          </a:p>
+        </p:txBody>
+      </p:sp>
+    </p:spTree>
+  </p:cSld>
+  <p:clrMapOvr>
+    <a:masterClrMapping/>
+  </p:clrMapOvr>
+</p:sld>
+</file>
+
+<file path=ppt/slides/slide17.xml><?xml version="1.0" encoding="utf-8"?>
+<p:sld xmlns:a="http://schemas.openxmlformats.org/drawingml/2006/main" xmlns:p="http://schemas.openxmlformats.org/presentationml/2006/main" xmlns:r="http://schemas.openxmlformats.org/officeDocument/2006/relationships">
+  <p:cSld>
+    <p:spTree>
+      <p:nvGrpSpPr>
+        <p:cNvPr id="1" name=""/>
+        <p:cNvGrpSpPr/>
+        <p:nvPr/>
+      </p:nvGrpSpPr>
+      <p:grpSpPr/>
+      <p:sp>
+        <p:nvSpPr>
+          <p:cNvPr id="2" name="Rectangle 1"/>
+          <p:cNvSpPr/>
+          <p:nvPr/>
+        </p:nvSpPr>
+        <p:spPr>
+          <a:xfrm>
+            <a:off x="0" y="0"/>
+            <a:ext cx="12191695" cy="6858000"/>
+          </a:xfrm>
+          <a:prstGeom prst="rect">
+            <a:avLst/>
+          </a:prstGeom>
+          <a:solidFill>
+            <a:srgbClr val="F4F7FA"/>
+          </a:solidFill>
+          <a:ln>
+            <a:noFill/>
+          </a:ln>
+        </p:spPr>
+        <p:style>
+          <a:lnRef idx="1">
+            <a:schemeClr val="accent1"/>
+          </a:lnRef>
+          <a:fillRef idx="3">
+            <a:schemeClr val="accent1"/>
+          </a:fillRef>
+          <a:effectRef idx="2">
+            <a:schemeClr val="accent1"/>
+          </a:effectRef>
+          <a:fontRef idx="minor">
+            <a:schemeClr val="lt1"/>
+          </a:fontRef>
+        </p:style>
+        <p:txBody>
+          <a:bodyPr rtlCol="0" anchor="ctr"/>
+          <a:lstStyle/>
+          <a:p>
+            <a:pPr algn="ctr"/>
+          </a:p>
+        </p:txBody>
+      </p:sp>
+      <p:sp>
+        <p:nvSpPr>
+          <p:cNvPr id="3" name="Rectangle 2"/>
+          <p:cNvSpPr/>
+          <p:nvPr/>
+        </p:nvSpPr>
+        <p:spPr>
+          <a:xfrm>
+            <a:off x="0" y="0"/>
+            <a:ext cx="12191695" cy="100584"/>
+          </a:xfrm>
+          <a:prstGeom prst="rect">
+            <a:avLst/>
+          </a:prstGeom>
+          <a:solidFill>
+            <a:srgbClr val="007F83"/>
+          </a:solidFill>
+          <a:ln>
+            <a:noFill/>
+          </a:ln>
+        </p:spPr>
+        <p:style>
+          <a:lnRef idx="1">
+            <a:schemeClr val="accent1"/>
+          </a:lnRef>
+          <a:fillRef idx="3">
+            <a:schemeClr val="accent1"/>
+          </a:fillRef>
+          <a:effectRef idx="2">
+            <a:schemeClr val="accent1"/>
+          </a:effectRef>
+          <a:fontRef idx="minor">
+            <a:schemeClr val="lt1"/>
+          </a:fontRef>
+        </p:style>
+        <p:txBody>
+          <a:bodyPr rtlCol="0" anchor="ctr"/>
+          <a:lstStyle/>
+          <a:p>
+            <a:pPr algn="ctr"/>
+          </a:p>
+        </p:txBody>
+      </p:sp>
+      <p:sp>
+        <p:nvSpPr>
+          <p:cNvPr id="4" name="TextBox 3"/>
+          <p:cNvSpPr txBox="1"/>
+          <p:nvPr/>
+        </p:nvSpPr>
+        <p:spPr>
+          <a:xfrm>
+            <a:off x="502920" y="301752"/>
+            <a:ext cx="10972800" cy="274320"/>
+          </a:xfrm>
+          <a:prstGeom prst="rect">
+            <a:avLst/>
+          </a:prstGeom>
+          <a:noFill/>
+        </p:spPr>
+        <p:txBody>
+          <a:bodyPr wrap="none" lIns="0" rIns="0" tIns="0" bIns="0">
+            <a:spAutoFit/>
+          </a:bodyPr>
+          <a:lstStyle/>
+          <a:p>
+            <a:pPr>
+              <a:lnSpc>
+                <a:spcPts val="1439"/>
+              </a:lnSpc>
+              <a:spcAft>
+                <a:spcPts val="0"/>
+              </a:spcAft>
+              <a:defRPr sz="1200" b="1">
+                <a:solidFill>
+                  <a:srgbClr val="007F83"/>
+                </a:solidFill>
+                <a:latin typeface="DejaVu Sans"/>
+              </a:defRPr>
+            </a:pPr>
+            <a:r>
               <a:t>APPENDIX • SOURCES</a:t>
             </a:r>
           </a:p>
@@ -14617,7 +16612,7 @@
               </a:defRPr>
             </a:pPr>
             <a:r>
-              <a:t>15</a:t>
+              <a:t>17</a:t>
             </a:r>
           </a:p>
         </p:txBody>

</xml_diff>